<commit_message>
Add pipeline slide deck PPTX
</commit_message>
<xml_diff>
--- a/docs/pipeline_slides.pptx
+++ b/docs/pipeline_slides.pptx
@@ -7,19 +7,19 @@
   <p:sldIdLst>
     <p:sldId id="256" r:id="rId7"/>
     <p:sldId id="257" r:id="rId8"/>
-    <p:sldId id="258" r:id="rId9"/>
-    <p:sldId id="259" r:id="rId10"/>
-    <p:sldId id="260" r:id="rId11"/>
-    <p:sldId id="261" r:id="rId12"/>
-    <p:sldId id="262" r:id="rId13"/>
-    <p:sldId id="263" r:id="rId14"/>
-    <p:sldId id="264" r:id="rId15"/>
-    <p:sldId id="265" r:id="rId16"/>
-    <p:sldId id="266" r:id="rId17"/>
-    <p:sldId id="267" r:id="rId18"/>
-    <p:sldId id="268" r:id="rId19"/>
+    <p:sldId id="258" r:id="rId10"/>
+    <p:sldId id="259" r:id="rId11"/>
+    <p:sldId id="260" r:id="rId12"/>
+    <p:sldId id="261" r:id="rId13"/>
+    <p:sldId id="262" r:id="rId14"/>
+    <p:sldId id="263" r:id="rId15"/>
+    <p:sldId id="264" r:id="rId16"/>
+    <p:sldId id="265" r:id="rId17"/>
+    <p:sldId id="266" r:id="rId18"/>
+    <p:sldId id="267" r:id="rId19"/>
+    <p:sldId id="268" r:id="rId20"/>
   </p:sldIdLst>
-  <p:sldSz cx="9144000" cy="6858000" type="screen4x3"/>
+  <p:sldSz cx="12188952" cy="6858000" type="screen4x3"/>
   <p:notesSz cx="6858000" cy="9144000"/>
   <p:defaultTextStyle>
     <a:defPPr>
@@ -117,6 +117,1529 @@
     </a:lvl9pPr>
   </p:defaultTextStyle>
 </p:presentation>
+</file>
+
+<file path=ppt/notesMasters/notesMaster1.xml><?xml version="1.0" encoding="utf-8"?>
+<p:notesMaster xmlns:a="http://schemas.openxmlformats.org/drawingml/2006/main" xmlns:p="http://schemas.openxmlformats.org/presentationml/2006/main" xmlns:r="http://schemas.openxmlformats.org/officeDocument/2006/relationships">
+  <p:cSld>
+    <p:bg>
+      <p:bgRef idx="1001">
+        <a:schemeClr val="bg1"/>
+      </p:bgRef>
+    </p:bg>
+    <p:spTree>
+      <p:nvGrpSpPr>
+        <p:cNvPr id="1" name=""/>
+        <p:cNvGrpSpPr/>
+        <p:nvPr/>
+      </p:nvGrpSpPr>
+      <p:grpSpPr>
+        <a:xfrm>
+          <a:off x="0" y="0"/>
+          <a:ext cx="0" cy="0"/>
+          <a:chOff x="0" y="0"/>
+          <a:chExt cx="0" cy="0"/>
+        </a:xfrm>
+      </p:grpSpPr>
+      <p:sp>
+        <p:nvSpPr>
+          <p:cNvPr id="2" name="Header Placeholder 1"/>
+          <p:cNvSpPr>
+            <a:spLocks noGrp="1"/>
+          </p:cNvSpPr>
+          <p:nvPr>
+            <p:ph type="hdr" sz="quarter"/>
+          </p:nvPr>
+        </p:nvSpPr>
+        <p:spPr>
+          <a:xfrm>
+            <a:off x="0" y="0"/>
+            <a:ext cx="2971800" cy="457200"/>
+          </a:xfrm>
+          <a:prstGeom prst="rect">
+            <a:avLst/>
+          </a:prstGeom>
+        </p:spPr>
+        <p:txBody>
+          <a:bodyPr vert="horz" lIns="91440" tIns="45720" rIns="91440" bIns="45720" rtlCol="0"/>
+          <a:lstStyle>
+            <a:lvl1pPr algn="l">
+              <a:defRPr sz="1200"/>
+            </a:lvl1pPr>
+          </a:lstStyle>
+          <a:p>
+            <a:endParaRPr lang="en-US"/>
+          </a:p>
+        </p:txBody>
+      </p:sp>
+      <p:sp>
+        <p:nvSpPr>
+          <p:cNvPr id="3" name="Date Placeholder 2"/>
+          <p:cNvSpPr>
+            <a:spLocks noGrp="1"/>
+          </p:cNvSpPr>
+          <p:nvPr>
+            <p:ph type="dt" idx="1"/>
+          </p:nvPr>
+        </p:nvSpPr>
+        <p:spPr>
+          <a:xfrm>
+            <a:off x="3884613" y="0"/>
+            <a:ext cx="2971800" cy="457200"/>
+          </a:xfrm>
+          <a:prstGeom prst="rect">
+            <a:avLst/>
+          </a:prstGeom>
+        </p:spPr>
+        <p:txBody>
+          <a:bodyPr vert="horz" lIns="91440" tIns="45720" rIns="91440" bIns="45720" rtlCol="0"/>
+          <a:lstStyle>
+            <a:lvl1pPr algn="r">
+              <a:defRPr sz="1200"/>
+            </a:lvl1pPr>
+          </a:lstStyle>
+          <a:p>
+            <a:fld id="{0F89C1C7-3DCD-1040-A9CF-14679D8B5DDD}" type="datetimeFigureOut">
+              <a:rPr lang="en-US" smtClean="0"/>
+              <a:t>10/17/16</a:t>
+            </a:fld>
+            <a:endParaRPr lang="en-US"/>
+          </a:p>
+        </p:txBody>
+      </p:sp>
+      <p:sp>
+        <p:nvSpPr>
+          <p:cNvPr id="4" name="Slide Image Placeholder 3"/>
+          <p:cNvSpPr>
+            <a:spLocks noGrp="1" noRot="1" noChangeAspect="1"/>
+          </p:cNvSpPr>
+          <p:nvPr>
+            <p:ph type="sldImg" idx="2"/>
+          </p:nvPr>
+        </p:nvSpPr>
+        <p:spPr>
+          <a:xfrm>
+            <a:off x="1143000" y="685800"/>
+            <a:ext cx="4572000" cy="3429000"/>
+          </a:xfrm>
+          <a:prstGeom prst="rect">
+            <a:avLst/>
+          </a:prstGeom>
+          <a:noFill/>
+          <a:ln w="12700">
+            <a:solidFill>
+              <a:prstClr val="black"/>
+            </a:solidFill>
+          </a:ln>
+        </p:spPr>
+        <p:txBody>
+          <a:bodyPr vert="horz" lIns="91440" tIns="45720" rIns="91440" bIns="45720" rtlCol="0" anchor="ctr"/>
+          <a:lstStyle/>
+          <a:p>
+            <a:endParaRPr lang="en-US"/>
+          </a:p>
+        </p:txBody>
+      </p:sp>
+      <p:sp>
+        <p:nvSpPr>
+          <p:cNvPr id="5" name="Notes Placeholder 4"/>
+          <p:cNvSpPr>
+            <a:spLocks noGrp="1"/>
+          </p:cNvSpPr>
+          <p:nvPr>
+            <p:ph type="body" sz="quarter" idx="3"/>
+          </p:nvPr>
+        </p:nvSpPr>
+        <p:spPr>
+          <a:xfrm>
+            <a:off x="685800" y="4343400"/>
+            <a:ext cx="5486400" cy="4114800"/>
+          </a:xfrm>
+          <a:prstGeom prst="rect">
+            <a:avLst/>
+          </a:prstGeom>
+        </p:spPr>
+        <p:txBody>
+          <a:bodyPr vert="horz" lIns="91440" tIns="45720" rIns="91440" bIns="45720" rtlCol="0"/>
+          <a:lstStyle/>
+          <a:p>
+            <a:pPr lvl="0"/>
+            <a:r>
+              <a:rPr lang="en-US" smtClean="0"/>
+              <a:t>Click to edit Master text styles</a:t>
+            </a:r>
+          </a:p>
+          <a:p>
+            <a:pPr lvl="1"/>
+            <a:r>
+              <a:rPr lang="en-US" smtClean="0"/>
+              <a:t>Second level</a:t>
+            </a:r>
+          </a:p>
+          <a:p>
+            <a:pPr lvl="2"/>
+            <a:r>
+              <a:rPr lang="en-US" smtClean="0"/>
+              <a:t>Third level</a:t>
+            </a:r>
+          </a:p>
+          <a:p>
+            <a:pPr lvl="3"/>
+            <a:r>
+              <a:rPr lang="en-US" smtClean="0"/>
+              <a:t>Fourth level</a:t>
+            </a:r>
+          </a:p>
+          <a:p>
+            <a:pPr lvl="4"/>
+            <a:r>
+              <a:rPr lang="en-US" smtClean="0"/>
+              <a:t>Fifth level</a:t>
+            </a:r>
+            <a:endParaRPr lang="en-US"/>
+          </a:p>
+        </p:txBody>
+      </p:sp>
+      <p:sp>
+        <p:nvSpPr>
+          <p:cNvPr id="6" name="Footer Placeholder 5"/>
+          <p:cNvSpPr>
+            <a:spLocks noGrp="1"/>
+          </p:cNvSpPr>
+          <p:nvPr>
+            <p:ph type="ftr" sz="quarter" idx="4"/>
+          </p:nvPr>
+        </p:nvSpPr>
+        <p:spPr>
+          <a:xfrm>
+            <a:off x="0" y="8685213"/>
+            <a:ext cx="2971800" cy="457200"/>
+          </a:xfrm>
+          <a:prstGeom prst="rect">
+            <a:avLst/>
+          </a:prstGeom>
+        </p:spPr>
+        <p:txBody>
+          <a:bodyPr vert="horz" lIns="91440" tIns="45720" rIns="91440" bIns="45720" rtlCol="0" anchor="b"/>
+          <a:lstStyle>
+            <a:lvl1pPr algn="l">
+              <a:defRPr sz="1200"/>
+            </a:lvl1pPr>
+          </a:lstStyle>
+          <a:p>
+            <a:endParaRPr lang="en-US"/>
+          </a:p>
+        </p:txBody>
+      </p:sp>
+      <p:sp>
+        <p:nvSpPr>
+          <p:cNvPr id="7" name="Slide Number Placeholder 6"/>
+          <p:cNvSpPr>
+            <a:spLocks noGrp="1"/>
+          </p:cNvSpPr>
+          <p:nvPr>
+            <p:ph type="sldNum" sz="quarter" idx="5"/>
+          </p:nvPr>
+        </p:nvSpPr>
+        <p:spPr>
+          <a:xfrm>
+            <a:off x="3884613" y="8685213"/>
+            <a:ext cx="2971800" cy="457200"/>
+          </a:xfrm>
+          <a:prstGeom prst="rect">
+            <a:avLst/>
+          </a:prstGeom>
+        </p:spPr>
+        <p:txBody>
+          <a:bodyPr vert="horz" lIns="91440" tIns="45720" rIns="91440" bIns="45720" rtlCol="0" anchor="b"/>
+          <a:lstStyle>
+            <a:lvl1pPr algn="r">
+              <a:defRPr sz="1200"/>
+            </a:lvl1pPr>
+          </a:lstStyle>
+          <a:p>
+            <a:fld id="{BB5E49A5-4136-284D-997B-48E1D791AD67}" type="slidenum">
+              <a:rPr lang="en-US" smtClean="0"/>
+              <a:t>‹#›</a:t>
+            </a:fld>
+            <a:endParaRPr lang="en-US"/>
+          </a:p>
+        </p:txBody>
+      </p:sp>
+    </p:spTree>
+    <p:extLst>
+      <p:ext uri="{BB962C8B-B14F-4D97-AF65-F5344CB8AC3E}">
+        <p14:creationId xmlns:p14="http://schemas.microsoft.com/office/powerpoint/2010/main" val="2623252185"/>
+      </p:ext>
+    </p:extLst>
+  </p:cSld>
+  <p:clrMap bg1="lt1" tx1="dk1" bg2="lt2" tx2="dk2" accent1="accent1" accent2="accent2" accent3="accent3" accent4="accent4" accent5="accent5" accent6="accent6" hlink="hlink" folHlink="folHlink"/>
+  <p:notesStyle>
+    <a:lvl1pPr marL="0" algn="l" defTabSz="457200" rtl="0" eaLnBrk="1" latinLnBrk="0" hangingPunct="1">
+      <a:defRPr sz="1200" kern="1200">
+        <a:solidFill>
+          <a:schemeClr val="tx1"/>
+        </a:solidFill>
+        <a:latin typeface="+mn-lt"/>
+        <a:ea typeface="+mn-ea"/>
+        <a:cs typeface="+mn-cs"/>
+      </a:defRPr>
+    </a:lvl1pPr>
+    <a:lvl2pPr marL="457200" algn="l" defTabSz="457200" rtl="0" eaLnBrk="1" latinLnBrk="0" hangingPunct="1">
+      <a:defRPr sz="1200" kern="1200">
+        <a:solidFill>
+          <a:schemeClr val="tx1"/>
+        </a:solidFill>
+        <a:latin typeface="+mn-lt"/>
+        <a:ea typeface="+mn-ea"/>
+        <a:cs typeface="+mn-cs"/>
+      </a:defRPr>
+    </a:lvl2pPr>
+    <a:lvl3pPr marL="914400" algn="l" defTabSz="457200" rtl="0" eaLnBrk="1" latinLnBrk="0" hangingPunct="1">
+      <a:defRPr sz="1200" kern="1200">
+        <a:solidFill>
+          <a:schemeClr val="tx1"/>
+        </a:solidFill>
+        <a:latin typeface="+mn-lt"/>
+        <a:ea typeface="+mn-ea"/>
+        <a:cs typeface="+mn-cs"/>
+      </a:defRPr>
+    </a:lvl3pPr>
+    <a:lvl4pPr marL="1371600" algn="l" defTabSz="457200" rtl="0" eaLnBrk="1" latinLnBrk="0" hangingPunct="1">
+      <a:defRPr sz="1200" kern="1200">
+        <a:solidFill>
+          <a:schemeClr val="tx1"/>
+        </a:solidFill>
+        <a:latin typeface="+mn-lt"/>
+        <a:ea typeface="+mn-ea"/>
+        <a:cs typeface="+mn-cs"/>
+      </a:defRPr>
+    </a:lvl4pPr>
+    <a:lvl5pPr marL="1828800" algn="l" defTabSz="457200" rtl="0" eaLnBrk="1" latinLnBrk="0" hangingPunct="1">
+      <a:defRPr sz="1200" kern="1200">
+        <a:solidFill>
+          <a:schemeClr val="tx1"/>
+        </a:solidFill>
+        <a:latin typeface="+mn-lt"/>
+        <a:ea typeface="+mn-ea"/>
+        <a:cs typeface="+mn-cs"/>
+      </a:defRPr>
+    </a:lvl5pPr>
+    <a:lvl6pPr marL="2286000" algn="l" defTabSz="457200" rtl="0" eaLnBrk="1" latinLnBrk="0" hangingPunct="1">
+      <a:defRPr sz="1200" kern="1200">
+        <a:solidFill>
+          <a:schemeClr val="tx1"/>
+        </a:solidFill>
+        <a:latin typeface="+mn-lt"/>
+        <a:ea typeface="+mn-ea"/>
+        <a:cs typeface="+mn-cs"/>
+      </a:defRPr>
+    </a:lvl6pPr>
+    <a:lvl7pPr marL="2743200" algn="l" defTabSz="457200" rtl="0" eaLnBrk="1" latinLnBrk="0" hangingPunct="1">
+      <a:defRPr sz="1200" kern="1200">
+        <a:solidFill>
+          <a:schemeClr val="tx1"/>
+        </a:solidFill>
+        <a:latin typeface="+mn-lt"/>
+        <a:ea typeface="+mn-ea"/>
+        <a:cs typeface="+mn-cs"/>
+      </a:defRPr>
+    </a:lvl7pPr>
+    <a:lvl8pPr marL="3200400" algn="l" defTabSz="457200" rtl="0" eaLnBrk="1" latinLnBrk="0" hangingPunct="1">
+      <a:defRPr sz="1200" kern="1200">
+        <a:solidFill>
+          <a:schemeClr val="tx1"/>
+        </a:solidFill>
+        <a:latin typeface="+mn-lt"/>
+        <a:ea typeface="+mn-ea"/>
+        <a:cs typeface="+mn-cs"/>
+      </a:defRPr>
+    </a:lvl8pPr>
+    <a:lvl9pPr marL="3657600" algn="l" defTabSz="457200" rtl="0" eaLnBrk="1" latinLnBrk="0" hangingPunct="1">
+      <a:defRPr sz="1200" kern="1200">
+        <a:solidFill>
+          <a:schemeClr val="tx1"/>
+        </a:solidFill>
+        <a:latin typeface="+mn-lt"/>
+        <a:ea typeface="+mn-ea"/>
+        <a:cs typeface="+mn-cs"/>
+      </a:defRPr>
+    </a:lvl9pPr>
+  </p:notesStyle>
+</p:notesMaster>
+</file>
+
+<file path=ppt/notesSlides/notesSlide1.xml><?xml version="1.0" encoding="utf-8"?>
+<p:notes xmlns:a="http://schemas.openxmlformats.org/drawingml/2006/main" xmlns:p="http://schemas.openxmlformats.org/presentationml/2006/main" xmlns:r="http://schemas.openxmlformats.org/officeDocument/2006/relationships">
+  <p:cSld>
+    <p:spTree>
+      <p:nvGrpSpPr>
+        <p:cNvPr id="1" name=""/>
+        <p:cNvGrpSpPr/>
+        <p:nvPr/>
+      </p:nvGrpSpPr>
+      <p:grpSpPr>
+        <a:xfrm>
+          <a:off x="0" y="0"/>
+          <a:ext cx="0" cy="0"/>
+          <a:chOff x="0" y="0"/>
+          <a:chExt cx="0" cy="0"/>
+        </a:xfrm>
+      </p:grpSpPr>
+      <p:sp>
+        <p:nvSpPr>
+          <p:cNvPr id="2" name="Slide Image Placeholder 1"/>
+          <p:cNvSpPr>
+            <a:spLocks noGrp="1"/>
+          </p:cNvSpPr>
+          <p:nvPr>
+            <p:ph type="sldImg" idx="2"/>
+          </p:nvPr>
+        </p:nvSpPr>
+        <p:spPr/>
+      </p:sp>
+      <p:sp>
+        <p:nvSpPr>
+          <p:cNvPr id="3" name="Notes Placeholder 2"/>
+          <p:cNvSpPr>
+            <a:spLocks noGrp="1"/>
+          </p:cNvSpPr>
+          <p:nvPr>
+            <p:ph type="body" idx="3" sz="quarter"/>
+          </p:nvPr>
+        </p:nvSpPr>
+        <p:spPr/>
+        <p:txBody>
+          <a:bodyPr/>
+          <a:lstStyle/>
+          <a:p>
+            <a:r>
+              <a:t>Slide 2</a:t>
+            </a:r>
+          </a:p>
+          <a:p/>
+          <a:p>
+            <a:r>
+              <a:t>Slide 2 — Goals</a:t>
+            </a:r>
+          </a:p>
+          <a:p>
+            <a:r>
+              <a:t>Identify robust EEG biomarkers that discriminate pain vs no‑pain</a:t>
+            </a:r>
+          </a:p>
+          <a:p>
+            <a:r>
+              <a:t>Produce leakage-safe held‑out validation (LOSO)</a:t>
+            </a:r>
+          </a:p>
+          <a:p>
+            <a:r>
+              <a:t>Provide a deployable, interpretable model and an audit trail for reproducibility</a:t>
+            </a:r>
+          </a:p>
+        </p:txBody>
+      </p:sp>
+      <p:sp>
+        <p:nvSpPr>
+          <p:cNvPr id="4" name="Slide Number Placeholder 3"/>
+          <p:cNvSpPr>
+            <a:spLocks noGrp="1"/>
+          </p:cNvSpPr>
+          <p:nvPr>
+            <p:ph type="sldNum" idx="5" sz="quarter"/>
+          </p:nvPr>
+        </p:nvSpPr>
+        <p:spPr/>
+      </p:sp>
+    </p:spTree>
+  </p:cSld>
+  <p:clrMapOvr>
+    <a:masterClrMapping/>
+  </p:clrMapOvr>
+</p:notes>
+</file>
+
+<file path=ppt/notesSlides/notesSlide10.xml><?xml version="1.0" encoding="utf-8"?>
+<p:notes xmlns:a="http://schemas.openxmlformats.org/drawingml/2006/main" xmlns:p="http://schemas.openxmlformats.org/presentationml/2006/main" xmlns:r="http://schemas.openxmlformats.org/officeDocument/2006/relationships">
+  <p:cSld>
+    <p:spTree>
+      <p:nvGrpSpPr>
+        <p:cNvPr id="1" name=""/>
+        <p:cNvGrpSpPr/>
+        <p:nvPr/>
+      </p:nvGrpSpPr>
+      <p:grpSpPr>
+        <a:xfrm>
+          <a:off x="0" y="0"/>
+          <a:ext cx="0" cy="0"/>
+          <a:chOff x="0" y="0"/>
+          <a:chExt cx="0" cy="0"/>
+        </a:xfrm>
+      </p:grpSpPr>
+      <p:sp>
+        <p:nvSpPr>
+          <p:cNvPr id="2" name="Slide Image Placeholder 1"/>
+          <p:cNvSpPr>
+            <a:spLocks noGrp="1"/>
+          </p:cNvSpPr>
+          <p:nvPr>
+            <p:ph type="sldImg" idx="2"/>
+          </p:nvPr>
+        </p:nvSpPr>
+        <p:spPr/>
+      </p:sp>
+      <p:sp>
+        <p:nvSpPr>
+          <p:cNvPr id="3" name="Notes Placeholder 2"/>
+          <p:cNvSpPr>
+            <a:spLocks noGrp="1"/>
+          </p:cNvSpPr>
+          <p:nvPr>
+            <p:ph type="body" idx="3" sz="quarter"/>
+          </p:nvPr>
+        </p:nvSpPr>
+        <p:spPr/>
+        <p:txBody>
+          <a:bodyPr/>
+          <a:lstStyle/>
+          <a:p>
+            <a:r>
+              <a:t>Slide 11</a:t>
+            </a:r>
+          </a:p>
+          <a:p/>
+          <a:p>
+            <a:r>
+              <a:t>Slide 11 — Action items for a new dataset</a:t>
+            </a:r>
+          </a:p>
+          <a:p>
+            <a:r>
+              <a:t>Prepare channels.tsv; verify event structure and stimulus timing</a:t>
+            </a:r>
+          </a:p>
+          <a:p>
+            <a:r>
+              <a:t>Run preprocessing; save QC; extract baseline 135 features</a:t>
+            </a:r>
+          </a:p>
+          <a:p>
+            <a:r>
+              <a:t>Run LOSO with training-only scaling &amp; selection; run family ablations</a:t>
+            </a:r>
+          </a:p>
+          <a:p>
+            <a:r>
+              <a:t>If stable biomarkers appear, retrain compact model for deployment; validate on external dataset if available</a:t>
+            </a:r>
+          </a:p>
+        </p:txBody>
+      </p:sp>
+      <p:sp>
+        <p:nvSpPr>
+          <p:cNvPr id="4" name="Slide Number Placeholder 3"/>
+          <p:cNvSpPr>
+            <a:spLocks noGrp="1"/>
+          </p:cNvSpPr>
+          <p:nvPr>
+            <p:ph type="sldNum" idx="5" sz="quarter"/>
+          </p:nvPr>
+        </p:nvSpPr>
+        <p:spPr/>
+      </p:sp>
+    </p:spTree>
+  </p:cSld>
+  <p:clrMapOvr>
+    <a:masterClrMapping/>
+  </p:clrMapOvr>
+</p:notes>
+</file>
+
+<file path=ppt/notesSlides/notesSlide11.xml><?xml version="1.0" encoding="utf-8"?>
+<p:notes xmlns:a="http://schemas.openxmlformats.org/drawingml/2006/main" xmlns:p="http://schemas.openxmlformats.org/presentationml/2006/main" xmlns:r="http://schemas.openxmlformats.org/officeDocument/2006/relationships">
+  <p:cSld>
+    <p:spTree>
+      <p:nvGrpSpPr>
+        <p:cNvPr id="1" name=""/>
+        <p:cNvGrpSpPr/>
+        <p:nvPr/>
+      </p:nvGrpSpPr>
+      <p:grpSpPr>
+        <a:xfrm>
+          <a:off x="0" y="0"/>
+          <a:ext cx="0" cy="0"/>
+          <a:chOff x="0" y="0"/>
+          <a:chExt cx="0" cy="0"/>
+        </a:xfrm>
+      </p:grpSpPr>
+      <p:sp>
+        <p:nvSpPr>
+          <p:cNvPr id="2" name="Slide Image Placeholder 1"/>
+          <p:cNvSpPr>
+            <a:spLocks noGrp="1"/>
+          </p:cNvSpPr>
+          <p:nvPr>
+            <p:ph type="sldImg" idx="2"/>
+          </p:nvPr>
+        </p:nvSpPr>
+        <p:spPr/>
+      </p:sp>
+      <p:sp>
+        <p:nvSpPr>
+          <p:cNvPr id="3" name="Notes Placeholder 2"/>
+          <p:cNvSpPr>
+            <a:spLocks noGrp="1"/>
+          </p:cNvSpPr>
+          <p:nvPr>
+            <p:ph type="body" idx="3" sz="quarter"/>
+          </p:nvPr>
+        </p:nvSpPr>
+        <p:spPr/>
+        <p:txBody>
+          <a:bodyPr/>
+          <a:lstStyle/>
+          <a:p>
+            <a:r>
+              <a:t>Slide 12</a:t>
+            </a:r>
+          </a:p>
+          <a:p/>
+          <a:p>
+            <a:r>
+              <a:t>Slide 12 — Contact / Next steps</a:t>
+            </a:r>
+          </a:p>
+          <a:p>
+            <a:r>
+              <a:t>Commit run outputs and config JSON for every experiment</a:t>
+            </a:r>
+          </a:p>
+          <a:p>
+            <a:r>
+              <a:t>Add subject-level QC thresholds and automated gating</a:t>
+            </a:r>
+          </a:p>
+          <a:p>
+            <a:r>
+              <a:t>Move toward real-time inference test with LDA on streaming ROI signals</a:t>
+            </a:r>
+          </a:p>
+        </p:txBody>
+      </p:sp>
+      <p:sp>
+        <p:nvSpPr>
+          <p:cNvPr id="4" name="Slide Number Placeholder 3"/>
+          <p:cNvSpPr>
+            <a:spLocks noGrp="1"/>
+          </p:cNvSpPr>
+          <p:nvPr>
+            <p:ph type="sldNum" idx="5" sz="quarter"/>
+          </p:nvPr>
+        </p:nvSpPr>
+        <p:spPr/>
+      </p:sp>
+    </p:spTree>
+  </p:cSld>
+  <p:clrMapOvr>
+    <a:masterClrMapping/>
+  </p:clrMapOvr>
+</p:notes>
+</file>
+
+<file path=ppt/notesSlides/notesSlide12.xml><?xml version="1.0" encoding="utf-8"?>
+<p:notes xmlns:a="http://schemas.openxmlformats.org/drawingml/2006/main" xmlns:p="http://schemas.openxmlformats.org/presentationml/2006/main" xmlns:r="http://schemas.openxmlformats.org/officeDocument/2006/relationships">
+  <p:cSld>
+    <p:spTree>
+      <p:nvGrpSpPr>
+        <p:cNvPr id="1" name=""/>
+        <p:cNvGrpSpPr/>
+        <p:nvPr/>
+      </p:nvGrpSpPr>
+      <p:grpSpPr>
+        <a:xfrm>
+          <a:off x="0" y="0"/>
+          <a:ext cx="0" cy="0"/>
+          <a:chOff x="0" y="0"/>
+          <a:chExt cx="0" cy="0"/>
+        </a:xfrm>
+      </p:grpSpPr>
+      <p:sp>
+        <p:nvSpPr>
+          <p:cNvPr id="2" name="Slide Image Placeholder 1"/>
+          <p:cNvSpPr>
+            <a:spLocks noGrp="1"/>
+          </p:cNvSpPr>
+          <p:nvPr>
+            <p:ph type="sldImg" idx="2"/>
+          </p:nvPr>
+        </p:nvSpPr>
+        <p:spPr/>
+      </p:sp>
+      <p:sp>
+        <p:nvSpPr>
+          <p:cNvPr id="3" name="Notes Placeholder 2"/>
+          <p:cNvSpPr>
+            <a:spLocks noGrp="1"/>
+          </p:cNvSpPr>
+          <p:nvPr>
+            <p:ph type="body" idx="3" sz="quarter"/>
+          </p:nvPr>
+        </p:nvSpPr>
+        <p:spPr/>
+        <p:txBody>
+          <a:bodyPr/>
+          <a:lstStyle/>
+          <a:p>
+            <a:r>
+              <a:t>Slide 13</a:t>
+            </a:r>
+          </a:p>
+          <a:p/>
+          <a:p/>
+        </p:txBody>
+      </p:sp>
+      <p:sp>
+        <p:nvSpPr>
+          <p:cNvPr id="4" name="Slide Number Placeholder 3"/>
+          <p:cNvSpPr>
+            <a:spLocks noGrp="1"/>
+          </p:cNvSpPr>
+          <p:nvPr>
+            <p:ph type="sldNum" idx="5" sz="quarter"/>
+          </p:nvPr>
+        </p:nvSpPr>
+        <p:spPr/>
+      </p:sp>
+    </p:spTree>
+  </p:cSld>
+  <p:clrMapOvr>
+    <a:masterClrMapping/>
+  </p:clrMapOvr>
+</p:notes>
+</file>
+
+<file path=ppt/notesSlides/notesSlide2.xml><?xml version="1.0" encoding="utf-8"?>
+<p:notes xmlns:a="http://schemas.openxmlformats.org/drawingml/2006/main" xmlns:p="http://schemas.openxmlformats.org/presentationml/2006/main" xmlns:r="http://schemas.openxmlformats.org/officeDocument/2006/relationships">
+  <p:cSld>
+    <p:spTree>
+      <p:nvGrpSpPr>
+        <p:cNvPr id="1" name=""/>
+        <p:cNvGrpSpPr/>
+        <p:nvPr/>
+      </p:nvGrpSpPr>
+      <p:grpSpPr>
+        <a:xfrm>
+          <a:off x="0" y="0"/>
+          <a:ext cx="0" cy="0"/>
+          <a:chOff x="0" y="0"/>
+          <a:chExt cx="0" cy="0"/>
+        </a:xfrm>
+      </p:grpSpPr>
+      <p:sp>
+        <p:nvSpPr>
+          <p:cNvPr id="2" name="Slide Image Placeholder 1"/>
+          <p:cNvSpPr>
+            <a:spLocks noGrp="1"/>
+          </p:cNvSpPr>
+          <p:nvPr>
+            <p:ph type="sldImg" idx="2"/>
+          </p:nvPr>
+        </p:nvSpPr>
+        <p:spPr/>
+      </p:sp>
+      <p:sp>
+        <p:nvSpPr>
+          <p:cNvPr id="3" name="Notes Placeholder 2"/>
+          <p:cNvSpPr>
+            <a:spLocks noGrp="1"/>
+          </p:cNvSpPr>
+          <p:nvPr>
+            <p:ph type="body" idx="3" sz="quarter"/>
+          </p:nvPr>
+        </p:nvSpPr>
+        <p:spPr/>
+        <p:txBody>
+          <a:bodyPr/>
+          <a:lstStyle/>
+          <a:p>
+            <a:r>
+              <a:t>Slide 3</a:t>
+            </a:r>
+          </a:p>
+          <a:p/>
+          <a:p>
+            <a:r>
+              <a:t>Slide 3 — Dataset &amp; Key facts</a:t>
+            </a:r>
+          </a:p>
+          <a:p>
+            <a:r>
+              <a:t>OpenNeuro ds005284 (Zhao et al.), Biosemi 64-channel, 1024 Hz (resampled to 256 Hz)</a:t>
+            </a:r>
+          </a:p>
+          <a:p>
+            <a:r>
+              <a:t>26 subjects, 781 epochs (367 pain / 414 no‑pain)</a:t>
+            </a:r>
+          </a:p>
+          <a:p>
+            <a:r>
+              <a:t>ROI: C3, CZ, C4 focused on somatosensory responses</a:t>
+            </a:r>
+          </a:p>
+        </p:txBody>
+      </p:sp>
+      <p:sp>
+        <p:nvSpPr>
+          <p:cNvPr id="4" name="Slide Number Placeholder 3"/>
+          <p:cNvSpPr>
+            <a:spLocks noGrp="1"/>
+          </p:cNvSpPr>
+          <p:nvPr>
+            <p:ph type="sldNum" idx="5" sz="quarter"/>
+          </p:nvPr>
+        </p:nvSpPr>
+        <p:spPr/>
+      </p:sp>
+    </p:spTree>
+  </p:cSld>
+  <p:clrMapOvr>
+    <a:masterClrMapping/>
+  </p:clrMapOvr>
+</p:notes>
+</file>
+
+<file path=ppt/notesSlides/notesSlide3.xml><?xml version="1.0" encoding="utf-8"?>
+<p:notes xmlns:a="http://schemas.openxmlformats.org/drawingml/2006/main" xmlns:p="http://schemas.openxmlformats.org/presentationml/2006/main" xmlns:r="http://schemas.openxmlformats.org/officeDocument/2006/relationships">
+  <p:cSld>
+    <p:spTree>
+      <p:nvGrpSpPr>
+        <p:cNvPr id="1" name=""/>
+        <p:cNvGrpSpPr/>
+        <p:nvPr/>
+      </p:nvGrpSpPr>
+      <p:grpSpPr>
+        <a:xfrm>
+          <a:off x="0" y="0"/>
+          <a:ext cx="0" cy="0"/>
+          <a:chOff x="0" y="0"/>
+          <a:chExt cx="0" cy="0"/>
+        </a:xfrm>
+      </p:grpSpPr>
+      <p:sp>
+        <p:nvSpPr>
+          <p:cNvPr id="2" name="Slide Image Placeholder 1"/>
+          <p:cNvSpPr>
+            <a:spLocks noGrp="1"/>
+          </p:cNvSpPr>
+          <p:nvPr>
+            <p:ph type="sldImg" idx="2"/>
+          </p:nvPr>
+        </p:nvSpPr>
+        <p:spPr/>
+      </p:sp>
+      <p:sp>
+        <p:nvSpPr>
+          <p:cNvPr id="3" name="Notes Placeholder 2"/>
+          <p:cNvSpPr>
+            <a:spLocks noGrp="1"/>
+          </p:cNvSpPr>
+          <p:nvPr>
+            <p:ph type="body" idx="3" sz="quarter"/>
+          </p:nvPr>
+        </p:nvSpPr>
+        <p:spPr/>
+        <p:txBody>
+          <a:bodyPr/>
+          <a:lstStyle/>
+          <a:p>
+            <a:r>
+              <a:t>Slide 4</a:t>
+            </a:r>
+          </a:p>
+          <a:p/>
+          <a:p>
+            <a:r>
+              <a:t>Slide 4 — Preprocessing pipeline (exact steps)</a:t>
+            </a:r>
+          </a:p>
+          <a:p>
+            <a:r>
+              <a:t>1. Channel mapping: map raw device labels → 10–20 (channels.tsv)</a:t>
+            </a:r>
+          </a:p>
+          <a:p>
+            <a:r>
+              <a:t>2. Resample: 1024 → 256 Hz</a:t>
+            </a:r>
+          </a:p>
+          <a:p>
+            <a:r>
+              <a:t>3. Notch: 50 Hz &amp; 100 Hz (adjust to 60 Hz mains if needed)</a:t>
+            </a:r>
+          </a:p>
+          <a:p>
+            <a:r>
+              <a:t>4. Bandpass: 0.5 – 80 Hz</a:t>
+            </a:r>
+          </a:p>
+          <a:p>
+            <a:r>
+              <a:t>5. Reference: average reference</a:t>
+            </a:r>
+          </a:p>
+          <a:p>
+            <a:r>
+              <a:t>6. Epoching:</a:t>
+            </a:r>
+          </a:p>
+          <a:p>
+            <a:r>
+              <a:t>Pain: 0 → +2 s relative to stimulus onset</a:t>
+            </a:r>
+          </a:p>
+          <a:p>
+            <a:r>
+              <a:t>No‑pain baseline: −5 → −3 s</a:t>
+            </a:r>
+          </a:p>
+          <a:p>
+            <a:r>
+              <a:t>7. Artifact rejection: amplitude threshold (|µV| &gt; 200)</a:t>
+            </a:r>
+          </a:p>
+          <a:p>
+            <a:r>
+              <a:t>8. Save per-epoch QC and per-subject summaries (audit CSVs)</a:t>
+            </a:r>
+          </a:p>
+        </p:txBody>
+      </p:sp>
+      <p:sp>
+        <p:nvSpPr>
+          <p:cNvPr id="4" name="Slide Number Placeholder 3"/>
+          <p:cNvSpPr>
+            <a:spLocks noGrp="1"/>
+          </p:cNvSpPr>
+          <p:nvPr>
+            <p:ph type="sldNum" idx="5" sz="quarter"/>
+          </p:nvPr>
+        </p:nvSpPr>
+        <p:spPr/>
+      </p:sp>
+    </p:spTree>
+  </p:cSld>
+  <p:clrMapOvr>
+    <a:masterClrMapping/>
+  </p:clrMapOvr>
+</p:notes>
+</file>
+
+<file path=ppt/notesSlides/notesSlide4.xml><?xml version="1.0" encoding="utf-8"?>
+<p:notes xmlns:a="http://schemas.openxmlformats.org/drawingml/2006/main" xmlns:p="http://schemas.openxmlformats.org/presentationml/2006/main" xmlns:r="http://schemas.openxmlformats.org/officeDocument/2006/relationships">
+  <p:cSld>
+    <p:spTree>
+      <p:nvGrpSpPr>
+        <p:cNvPr id="1" name=""/>
+        <p:cNvGrpSpPr/>
+        <p:nvPr/>
+      </p:nvGrpSpPr>
+      <p:grpSpPr>
+        <a:xfrm>
+          <a:off x="0" y="0"/>
+          <a:ext cx="0" cy="0"/>
+          <a:chOff x="0" y="0"/>
+          <a:chExt cx="0" cy="0"/>
+        </a:xfrm>
+      </p:grpSpPr>
+      <p:sp>
+        <p:nvSpPr>
+          <p:cNvPr id="2" name="Slide Image Placeholder 1"/>
+          <p:cNvSpPr>
+            <a:spLocks noGrp="1"/>
+          </p:cNvSpPr>
+          <p:nvPr>
+            <p:ph type="sldImg" idx="2"/>
+          </p:nvPr>
+        </p:nvSpPr>
+        <p:spPr/>
+      </p:sp>
+      <p:sp>
+        <p:nvSpPr>
+          <p:cNvPr id="3" name="Notes Placeholder 2"/>
+          <p:cNvSpPr>
+            <a:spLocks noGrp="1"/>
+          </p:cNvSpPr>
+          <p:nvPr>
+            <p:ph type="body" idx="3" sz="quarter"/>
+          </p:nvPr>
+        </p:nvSpPr>
+        <p:spPr/>
+        <p:txBody>
+          <a:bodyPr/>
+          <a:lstStyle/>
+          <a:p>
+            <a:r>
+              <a:t>Slide 5</a:t>
+            </a:r>
+          </a:p>
+          <a:p/>
+          <a:p>
+            <a:r>
+              <a:t>Slide 5 — Feature families (extract all for new datasets)</a:t>
+            </a:r>
+          </a:p>
+          <a:p>
+            <a:r>
+              <a:t>Spectral: abs/rel band power (δ,θ,α,β,low‑γ), band ratios, spectral centroid, median freq, 1/f slope</a:t>
+            </a:r>
+          </a:p>
+          <a:p>
+            <a:r>
+              <a:t>Nonlinear: Higuchi FD, Petrosian FD, DFA, sample &amp; permutation entropy, Lempel‑Ziv, Hjorth</a:t>
+            </a:r>
+          </a:p>
+          <a:p>
+            <a:r>
+              <a:t>Time-domain: RMS, STD, peak‑to‑peak, line length, zero-crossing rate, skew, kurtosis</a:t>
+            </a:r>
+          </a:p>
+          <a:p>
+            <a:r>
+              <a:t>Wavelet: db4 multiscale energy ratios, wavelet entropy</a:t>
+            </a:r>
+          </a:p>
+          <a:p>
+            <a:r>
+              <a:t>MFCC: first 5 MFCC means per channel</a:t>
+            </a:r>
+          </a:p>
+          <a:p>
+            <a:r>
+              <a:t>AR dynamics: Burg AR coefficients + innovation variance</a:t>
+            </a:r>
+          </a:p>
+          <a:p>
+            <a:r>
+              <a:t>Connectivity: coherence &amp; PLV for C3-CZ, C3-C4, CZ-C4 across bands</a:t>
+            </a:r>
+          </a:p>
+        </p:txBody>
+      </p:sp>
+      <p:sp>
+        <p:nvSpPr>
+          <p:cNvPr id="4" name="Slide Number Placeholder 3"/>
+          <p:cNvSpPr>
+            <a:spLocks noGrp="1"/>
+          </p:cNvSpPr>
+          <p:nvPr>
+            <p:ph type="sldNum" idx="5" sz="quarter"/>
+          </p:nvPr>
+        </p:nvSpPr>
+        <p:spPr/>
+      </p:sp>
+    </p:spTree>
+  </p:cSld>
+  <p:clrMapOvr>
+    <a:masterClrMapping/>
+  </p:clrMapOvr>
+</p:notes>
+</file>
+
+<file path=ppt/notesSlides/notesSlide5.xml><?xml version="1.0" encoding="utf-8"?>
+<p:notes xmlns:a="http://schemas.openxmlformats.org/drawingml/2006/main" xmlns:p="http://schemas.openxmlformats.org/presentationml/2006/main" xmlns:r="http://schemas.openxmlformats.org/officeDocument/2006/relationships">
+  <p:cSld>
+    <p:spTree>
+      <p:nvGrpSpPr>
+        <p:cNvPr id="1" name=""/>
+        <p:cNvGrpSpPr/>
+        <p:nvPr/>
+      </p:nvGrpSpPr>
+      <p:grpSpPr>
+        <a:xfrm>
+          <a:off x="0" y="0"/>
+          <a:ext cx="0" cy="0"/>
+          <a:chOff x="0" y="0"/>
+          <a:chExt cx="0" cy="0"/>
+        </a:xfrm>
+      </p:grpSpPr>
+      <p:sp>
+        <p:nvSpPr>
+          <p:cNvPr id="2" name="Slide Image Placeholder 1"/>
+          <p:cNvSpPr>
+            <a:spLocks noGrp="1"/>
+          </p:cNvSpPr>
+          <p:nvPr>
+            <p:ph type="sldImg" idx="2"/>
+          </p:nvPr>
+        </p:nvSpPr>
+        <p:spPr/>
+      </p:sp>
+      <p:sp>
+        <p:nvSpPr>
+          <p:cNvPr id="3" name="Notes Placeholder 2"/>
+          <p:cNvSpPr>
+            <a:spLocks noGrp="1"/>
+          </p:cNvSpPr>
+          <p:nvPr>
+            <p:ph type="body" idx="3" sz="quarter"/>
+          </p:nvPr>
+        </p:nvSpPr>
+        <p:spPr/>
+        <p:txBody>
+          <a:bodyPr/>
+          <a:lstStyle/>
+          <a:p>
+            <a:r>
+              <a:t>Slide 6</a:t>
+            </a:r>
+          </a:p>
+          <a:p/>
+          <a:p>
+            <a:r>
+              <a:t>Slide 6 — Feature naming &amp; storage</a:t>
+            </a:r>
+          </a:p>
+          <a:p>
+            <a:r>
+              <a:t>Use descriptive names: e.g., CZ_higuchi, C3_alpha_power, CZ_C4_lowgamma_plv</a:t>
+            </a:r>
+          </a:p>
+          <a:p>
+            <a:r>
+              <a:t>Save:</a:t>
+            </a:r>
+          </a:p>
+          <a:p>
+            <a:r>
+              <a:t>features CSV (rows = epochs, cols = features)</a:t>
+            </a:r>
+          </a:p>
+          <a:p>
+            <a:r>
+              <a:t>features NPZ (X, y, subjects, feature_names)</a:t>
+            </a:r>
+          </a:p>
+          <a:p>
+            <a:r>
+              <a:t>per-epoch QC CSV and subject_summary.csv</a:t>
+            </a:r>
+          </a:p>
+        </p:txBody>
+      </p:sp>
+      <p:sp>
+        <p:nvSpPr>
+          <p:cNvPr id="4" name="Slide Number Placeholder 3"/>
+          <p:cNvSpPr>
+            <a:spLocks noGrp="1"/>
+          </p:cNvSpPr>
+          <p:nvPr>
+            <p:ph type="sldNum" idx="5" sz="quarter"/>
+          </p:nvPr>
+        </p:nvSpPr>
+        <p:spPr/>
+      </p:sp>
+    </p:spTree>
+  </p:cSld>
+  <p:clrMapOvr>
+    <a:masterClrMapping/>
+  </p:clrMapOvr>
+</p:notes>
+</file>
+
+<file path=ppt/notesSlides/notesSlide6.xml><?xml version="1.0" encoding="utf-8"?>
+<p:notes xmlns:a="http://schemas.openxmlformats.org/drawingml/2006/main" xmlns:p="http://schemas.openxmlformats.org/presentationml/2006/main" xmlns:r="http://schemas.openxmlformats.org/officeDocument/2006/relationships">
+  <p:cSld>
+    <p:spTree>
+      <p:nvGrpSpPr>
+        <p:cNvPr id="1" name=""/>
+        <p:cNvGrpSpPr/>
+        <p:nvPr/>
+      </p:nvGrpSpPr>
+      <p:grpSpPr>
+        <a:xfrm>
+          <a:off x="0" y="0"/>
+          <a:ext cx="0" cy="0"/>
+          <a:chOff x="0" y="0"/>
+          <a:chExt cx="0" cy="0"/>
+        </a:xfrm>
+      </p:grpSpPr>
+      <p:sp>
+        <p:nvSpPr>
+          <p:cNvPr id="2" name="Slide Image Placeholder 1"/>
+          <p:cNvSpPr>
+            <a:spLocks noGrp="1"/>
+          </p:cNvSpPr>
+          <p:nvPr>
+            <p:ph type="sldImg" idx="2"/>
+          </p:nvPr>
+        </p:nvSpPr>
+        <p:spPr/>
+      </p:sp>
+      <p:sp>
+        <p:nvSpPr>
+          <p:cNvPr id="3" name="Notes Placeholder 2"/>
+          <p:cNvSpPr>
+            <a:spLocks noGrp="1"/>
+          </p:cNvSpPr>
+          <p:nvPr>
+            <p:ph type="body" idx="3" sz="quarter"/>
+          </p:nvPr>
+        </p:nvSpPr>
+        <p:spPr/>
+        <p:txBody>
+          <a:bodyPr/>
+          <a:lstStyle/>
+          <a:p>
+            <a:r>
+              <a:t>Slide 7</a:t>
+            </a:r>
+          </a:p>
+          <a:p/>
+          <a:p>
+            <a:r>
+              <a:t>Slide 7 — Validation (leakage-safe procedure)</a:t>
+            </a:r>
+          </a:p>
+          <a:p>
+            <a:r>
+              <a:t>1. Use Leave‑One‑Subject‑Out (LOSO) or appropriate grouped CV</a:t>
+            </a:r>
+          </a:p>
+          <a:p>
+            <a:r>
+              <a:t>2. For each training fold:</a:t>
+            </a:r>
+          </a:p>
+          <a:p>
+            <a:r>
+              <a:t>Replace non-finite, apply variance threshold (train-only)</a:t>
+            </a:r>
+          </a:p>
+          <a:p>
+            <a:r>
+              <a:t>Fit StandardScaler (train-only) → transform test</a:t>
+            </a:r>
+          </a:p>
+          <a:p>
+            <a:r>
+              <a:t>Compute ANOVA-F ranking on train → select top‑K (e.g., K=60)</a:t>
+            </a:r>
+          </a:p>
+          <a:p>
+            <a:r>
+              <a:t>Fit classifier (e.g., LDA with shrinkage)</a:t>
+            </a:r>
+          </a:p>
+          <a:p>
+            <a:r>
+              <a:t>3. Predict on held‑out subject; collect per-fold AUCs, sensitivities, specificities</a:t>
+            </a:r>
+          </a:p>
+          <a:p>
+            <a:r>
+              <a:t>4. Report mean AUC ± SD and per-subject metrics; use paired tests for ablations (Wilcoxon)</a:t>
+            </a:r>
+          </a:p>
+        </p:txBody>
+      </p:sp>
+      <p:sp>
+        <p:nvSpPr>
+          <p:cNvPr id="4" name="Slide Number Placeholder 3"/>
+          <p:cNvSpPr>
+            <a:spLocks noGrp="1"/>
+          </p:cNvSpPr>
+          <p:nvPr>
+            <p:ph type="sldNum" idx="5" sz="quarter"/>
+          </p:nvPr>
+        </p:nvSpPr>
+        <p:spPr/>
+      </p:sp>
+    </p:spTree>
+  </p:cSld>
+  <p:clrMapOvr>
+    <a:masterClrMapping/>
+  </p:clrMapOvr>
+</p:notes>
+</file>
+
+<file path=ppt/notesSlides/notesSlide7.xml><?xml version="1.0" encoding="utf-8"?>
+<p:notes xmlns:a="http://schemas.openxmlformats.org/drawingml/2006/main" xmlns:p="http://schemas.openxmlformats.org/presentationml/2006/main" xmlns:r="http://schemas.openxmlformats.org/officeDocument/2006/relationships">
+  <p:cSld>
+    <p:spTree>
+      <p:nvGrpSpPr>
+        <p:cNvPr id="1" name=""/>
+        <p:cNvGrpSpPr/>
+        <p:nvPr/>
+      </p:nvGrpSpPr>
+      <p:grpSpPr>
+        <a:xfrm>
+          <a:off x="0" y="0"/>
+          <a:ext cx="0" cy="0"/>
+          <a:chOff x="0" y="0"/>
+          <a:chExt cx="0" cy="0"/>
+        </a:xfrm>
+      </p:grpSpPr>
+      <p:sp>
+        <p:nvSpPr>
+          <p:cNvPr id="2" name="Slide Image Placeholder 1"/>
+          <p:cNvSpPr>
+            <a:spLocks noGrp="1"/>
+          </p:cNvSpPr>
+          <p:nvPr>
+            <p:ph type="sldImg" idx="2"/>
+          </p:nvPr>
+        </p:nvSpPr>
+        <p:spPr/>
+      </p:sp>
+      <p:sp>
+        <p:nvSpPr>
+          <p:cNvPr id="3" name="Notes Placeholder 2"/>
+          <p:cNvSpPr>
+            <a:spLocks noGrp="1"/>
+          </p:cNvSpPr>
+          <p:nvPr>
+            <p:ph type="body" idx="3" sz="quarter"/>
+          </p:nvPr>
+        </p:nvSpPr>
+        <p:spPr/>
+        <p:txBody>
+          <a:bodyPr/>
+          <a:lstStyle/>
+          <a:p>
+            <a:r>
+              <a:t>Slide 8</a:t>
+            </a:r>
+          </a:p>
+          <a:p/>
+          <a:p>
+            <a:r>
+              <a:t>Slide 8 — Recommended classifiers &amp; deployment</a:t>
+            </a:r>
+          </a:p>
+          <a:p>
+            <a:r>
+              <a:t>Research / exploration: RF / Gradient Boosting for ablation; check overfitting</a:t>
+            </a:r>
+          </a:p>
+          <a:p>
+            <a:r>
+              <a:t>Deployment / interpretability: LDA (shrinkage) on parsimonious set (e.g., top nonlinear CZ features)</a:t>
+            </a:r>
+          </a:p>
+          <a:p>
+            <a:r>
+              <a:t>Implement per-subject QC gating before decision-making</a:t>
+            </a:r>
+          </a:p>
+        </p:txBody>
+      </p:sp>
+      <p:sp>
+        <p:nvSpPr>
+          <p:cNvPr id="4" name="Slide Number Placeholder 3"/>
+          <p:cNvSpPr>
+            <a:spLocks noGrp="1"/>
+          </p:cNvSpPr>
+          <p:nvPr>
+            <p:ph type="sldNum" idx="5" sz="quarter"/>
+          </p:nvPr>
+        </p:nvSpPr>
+        <p:spPr/>
+      </p:sp>
+    </p:spTree>
+  </p:cSld>
+  <p:clrMapOvr>
+    <a:masterClrMapping/>
+  </p:clrMapOvr>
+</p:notes>
+</file>
+
+<file path=ppt/notesSlides/notesSlide8.xml><?xml version="1.0" encoding="utf-8"?>
+<p:notes xmlns:a="http://schemas.openxmlformats.org/drawingml/2006/main" xmlns:p="http://schemas.openxmlformats.org/presentationml/2006/main" xmlns:r="http://schemas.openxmlformats.org/officeDocument/2006/relationships">
+  <p:cSld>
+    <p:spTree>
+      <p:nvGrpSpPr>
+        <p:cNvPr id="1" name=""/>
+        <p:cNvGrpSpPr/>
+        <p:nvPr/>
+      </p:nvGrpSpPr>
+      <p:grpSpPr>
+        <a:xfrm>
+          <a:off x="0" y="0"/>
+          <a:ext cx="0" cy="0"/>
+          <a:chOff x="0" y="0"/>
+          <a:chExt cx="0" cy="0"/>
+        </a:xfrm>
+      </p:grpSpPr>
+      <p:sp>
+        <p:nvSpPr>
+          <p:cNvPr id="2" name="Slide Image Placeholder 1"/>
+          <p:cNvSpPr>
+            <a:spLocks noGrp="1"/>
+          </p:cNvSpPr>
+          <p:nvPr>
+            <p:ph type="sldImg" idx="2"/>
+          </p:nvPr>
+        </p:nvSpPr>
+        <p:spPr/>
+      </p:sp>
+      <p:sp>
+        <p:nvSpPr>
+          <p:cNvPr id="3" name="Notes Placeholder 2"/>
+          <p:cNvSpPr>
+            <a:spLocks noGrp="1"/>
+          </p:cNvSpPr>
+          <p:nvPr>
+            <p:ph type="body" idx="3" sz="quarter"/>
+          </p:nvPr>
+        </p:nvSpPr>
+        <p:spPr/>
+        <p:txBody>
+          <a:bodyPr/>
+          <a:lstStyle/>
+          <a:p>
+            <a:r>
+              <a:t>Slide 9</a:t>
+            </a:r>
+          </a:p>
+          <a:p/>
+          <a:p>
+            <a:r>
+              <a:t>Slide 9 — Ablation strategy</a:t>
+            </a:r>
+          </a:p>
+          <a:p>
+            <a:r>
+              <a:t>Baseline (135 features) vs Baseline + family (wavelet / MFCC / AR / connectivity)</a:t>
+            </a:r>
+          </a:p>
+          <a:p>
+            <a:r>
+              <a:t>Use the same LOSO splits and compute paired Wilcoxon tests across folds</a:t>
+            </a:r>
+          </a:p>
+          <a:p>
+            <a:r>
+              <a:t>Record fold-level outputs and config JSON for auditability</a:t>
+            </a:r>
+          </a:p>
+        </p:txBody>
+      </p:sp>
+      <p:sp>
+        <p:nvSpPr>
+          <p:cNvPr id="4" name="Slide Number Placeholder 3"/>
+          <p:cNvSpPr>
+            <a:spLocks noGrp="1"/>
+          </p:cNvSpPr>
+          <p:nvPr>
+            <p:ph type="sldNum" idx="5" sz="quarter"/>
+          </p:nvPr>
+        </p:nvSpPr>
+        <p:spPr/>
+      </p:sp>
+    </p:spTree>
+  </p:cSld>
+  <p:clrMapOvr>
+    <a:masterClrMapping/>
+  </p:clrMapOvr>
+</p:notes>
+</file>
+
+<file path=ppt/notesSlides/notesSlide9.xml><?xml version="1.0" encoding="utf-8"?>
+<p:notes xmlns:a="http://schemas.openxmlformats.org/drawingml/2006/main" xmlns:p="http://schemas.openxmlformats.org/presentationml/2006/main" xmlns:r="http://schemas.openxmlformats.org/officeDocument/2006/relationships">
+  <p:cSld>
+    <p:spTree>
+      <p:nvGrpSpPr>
+        <p:cNvPr id="1" name=""/>
+        <p:cNvGrpSpPr/>
+        <p:nvPr/>
+      </p:nvGrpSpPr>
+      <p:grpSpPr>
+        <a:xfrm>
+          <a:off x="0" y="0"/>
+          <a:ext cx="0" cy="0"/>
+          <a:chOff x="0" y="0"/>
+          <a:chExt cx="0" cy="0"/>
+        </a:xfrm>
+      </p:grpSpPr>
+      <p:sp>
+        <p:nvSpPr>
+          <p:cNvPr id="2" name="Slide Image Placeholder 1"/>
+          <p:cNvSpPr>
+            <a:spLocks noGrp="1"/>
+          </p:cNvSpPr>
+          <p:nvPr>
+            <p:ph type="sldImg" idx="2"/>
+          </p:nvPr>
+        </p:nvSpPr>
+        <p:spPr/>
+      </p:sp>
+      <p:sp>
+        <p:nvSpPr>
+          <p:cNvPr id="3" name="Notes Placeholder 2"/>
+          <p:cNvSpPr>
+            <a:spLocks noGrp="1"/>
+          </p:cNvSpPr>
+          <p:nvPr>
+            <p:ph type="body" idx="3" sz="quarter"/>
+          </p:nvPr>
+        </p:nvSpPr>
+        <p:spPr/>
+        <p:txBody>
+          <a:bodyPr/>
+          <a:lstStyle/>
+          <a:p>
+            <a:r>
+              <a:t>Slide 10</a:t>
+            </a:r>
+          </a:p>
+          <a:p/>
+          <a:p>
+            <a:r>
+              <a:t>Slide 10 — Typical outputs &amp; audit files</a:t>
+            </a:r>
+          </a:p>
+          <a:p>
+            <a:r>
+              <a:t>all_subjects_features.csv, features_xy.npz, classification_results.csv</a:t>
+            </a:r>
+          </a:p>
+          <a:p>
+            <a:r>
+              <a:t>per_subject_accuracy.csv, subject_summary.csv</a:t>
+            </a:r>
+          </a:p>
+          <a:p>
+            <a:r>
+              <a:t>biomarker_exploration_screening.csv, biomarker_loso_ablation_results.csv</a:t>
+            </a:r>
+          </a:p>
+          <a:p>
+            <a:r>
+              <a:t>Figures: ROC curves, feature heatmaps, per-subject violin plots</a:t>
+            </a:r>
+          </a:p>
+        </p:txBody>
+      </p:sp>
+      <p:sp>
+        <p:nvSpPr>
+          <p:cNvPr id="4" name="Slide Number Placeholder 3"/>
+          <p:cNvSpPr>
+            <a:spLocks noGrp="1"/>
+          </p:cNvSpPr>
+          <p:nvPr>
+            <p:ph type="sldNum" idx="5" sz="quarter"/>
+          </p:nvPr>
+        </p:nvSpPr>
+        <p:spPr/>
+      </p:sp>
+    </p:spTree>
+  </p:cSld>
+  <p:clrMapOvr>
+    <a:masterClrMapping/>
+  </p:clrMapOvr>
+</p:notes>
 </file>
 
 <file path=ppt/slideLayouts/slideLayout1.xml><?xml version="1.0" encoding="utf-8"?>
@@ -3093,6 +4616,14 @@
 <file path=ppt/slides/slide1.xml><?xml version="1.0" encoding="utf-8"?>
 <p:sld xmlns:a="http://schemas.openxmlformats.org/drawingml/2006/main" xmlns:p="http://schemas.openxmlformats.org/presentationml/2006/main" xmlns:r="http://schemas.openxmlformats.org/officeDocument/2006/relationships">
   <p:cSld>
+    <p:bg>
+      <p:bgPr>
+        <a:solidFill>
+          <a:srgbClr val="0A547E"/>
+        </a:solidFill>
+        <a:effectLst/>
+      </p:bgPr>
+    </p:bg>
     <p:spTree>
       <p:nvGrpSpPr>
         <p:cNvPr id="1" name=""/>
@@ -3102,19 +4633,34 @@
       <p:grpSpPr/>
       <p:sp>
         <p:nvSpPr>
-          <p:cNvPr id="2" name="Title 1"/>
-          <p:cNvSpPr>
-            <a:spLocks noGrp="1"/>
-          </p:cNvSpPr>
-          <p:nvPr>
-            <p:ph type="title"/>
-          </p:nvPr>
-        </p:nvSpPr>
-        <p:spPr/>
-        <p:txBody>
-          <a:bodyPr/>
-          <a:lstStyle/>
-          <a:p>
+          <p:cNvPr id="2" name="TextBox 1"/>
+          <p:cNvSpPr txBox="1"/>
+          <p:nvPr/>
+        </p:nvSpPr>
+        <p:spPr>
+          <a:xfrm>
+            <a:off x="548640" y="1097280"/>
+            <a:ext cx="7315200" cy="1645920"/>
+          </a:xfrm>
+          <a:prstGeom prst="rect">
+            <a:avLst/>
+          </a:prstGeom>
+          <a:noFill/>
+        </p:spPr>
+        <p:txBody>
+          <a:bodyPr wrap="none">
+            <a:spAutoFit/>
+          </a:bodyPr>
+          <a:lstStyle/>
+          <a:p>
+            <a:pPr>
+              <a:defRPr sz="4000" b="1">
+                <a:solidFill>
+                  <a:srgbClr val="FFFFFF"/>
+                </a:solidFill>
+                <a:latin typeface="Calibri"/>
+              </a:defRPr>
+            </a:pPr>
             <a:r>
               <a:t>EEG Pain Biomarker Pipeline — Overview</a:t>
             </a:r>
@@ -3123,48 +4669,36 @@
       </p:sp>
       <p:sp>
         <p:nvSpPr>
-          <p:cNvPr id="3" name="Content Placeholder 2"/>
-          <p:cNvSpPr>
-            <a:spLocks noGrp="1"/>
-          </p:cNvSpPr>
-          <p:nvPr>
-            <p:ph idx="1"/>
-          </p:nvPr>
-        </p:nvSpPr>
-        <p:spPr/>
-        <p:txBody>
-          <a:bodyPr/>
-          <a:lstStyle/>
-          <a:p>
-            <a:pPr>
-              <a:defRPr sz="1800"/>
+          <p:cNvPr id="3" name="TextBox 2"/>
+          <p:cNvSpPr txBox="1"/>
+          <p:nvPr/>
+        </p:nvSpPr>
+        <p:spPr>
+          <a:xfrm>
+            <a:off x="548640" y="2743200"/>
+            <a:ext cx="7315200" cy="914400"/>
+          </a:xfrm>
+          <a:prstGeom prst="rect">
+            <a:avLst/>
+          </a:prstGeom>
+          <a:noFill/>
+        </p:spPr>
+        <p:txBody>
+          <a:bodyPr wrap="none">
+            <a:spAutoFit/>
+          </a:bodyPr>
+          <a:lstStyle/>
+          <a:p>
+            <a:pPr>
+              <a:defRPr sz="2000" b="0">
+                <a:solidFill>
+                  <a:srgbClr val="FFFFFF"/>
+                </a:solidFill>
+                <a:latin typeface="Calibri"/>
+              </a:defRPr>
             </a:pPr>
             <a:r>
               <a:t>Slide 1 — Title</a:t>
-            </a:r>
-          </a:p>
-          <a:p>
-            <a:pPr>
-              <a:defRPr sz="1800"/>
-            </a:pPr>
-            <a:r>
-              <a:t>EEG Pain Biomarker Pipeline</a:t>
-            </a:r>
-          </a:p>
-          <a:p>
-            <a:pPr>
-              <a:defRPr sz="1800"/>
-            </a:pPr>
-            <a:r>
-              <a:t>Reproducible preprocessing, feature engineering, and LOSO validation for ds005284 (26 subjects)</a:t>
-            </a:r>
-          </a:p>
-          <a:p>
-            <a:pPr>
-              <a:defRPr sz="1800"/>
-            </a:pPr>
-            <a:r>
-              <a:t>Presenter: EEG Analysis Team</a:t>
             </a:r>
           </a:p>
         </p:txBody>
@@ -3180,6 +4714,14 @@
 <file path=ppt/slides/slide10.xml><?xml version="1.0" encoding="utf-8"?>
 <p:sld xmlns:a="http://schemas.openxmlformats.org/drawingml/2006/main" xmlns:p="http://schemas.openxmlformats.org/presentationml/2006/main" xmlns:r="http://schemas.openxmlformats.org/officeDocument/2006/relationships">
   <p:cSld>
+    <p:bg>
+      <p:bgPr>
+        <a:solidFill>
+          <a:srgbClr val="F5F7FA"/>
+        </a:solidFill>
+        <a:effectLst/>
+      </p:bgPr>
+    </p:bg>
     <p:spTree>
       <p:nvGrpSpPr>
         <p:cNvPr id="1" name=""/>
@@ -3189,42 +4731,69 @@
       <p:grpSpPr/>
       <p:sp>
         <p:nvSpPr>
-          <p:cNvPr id="2" name="Title 1"/>
-          <p:cNvSpPr>
-            <a:spLocks noGrp="1"/>
-          </p:cNvSpPr>
-          <p:nvPr>
-            <p:ph type="title"/>
-          </p:nvPr>
-        </p:nvSpPr>
-        <p:spPr/>
-        <p:txBody>
-          <a:bodyPr/>
-          <a:lstStyle/>
-          <a:p>
-            <a:r>
-              <a:t>Slide</a:t>
-            </a:r>
-          </a:p>
-        </p:txBody>
-      </p:sp>
-      <p:sp>
-        <p:nvSpPr>
-          <p:cNvPr id="3" name="Content Placeholder 2"/>
-          <p:cNvSpPr>
-            <a:spLocks noGrp="1"/>
-          </p:cNvSpPr>
-          <p:nvPr>
-            <p:ph idx="1"/>
-          </p:nvPr>
-        </p:nvSpPr>
-        <p:spPr/>
-        <p:txBody>
-          <a:bodyPr/>
-          <a:lstStyle/>
-          <a:p>
-            <a:pPr>
-              <a:defRPr sz="1800"/>
+          <p:cNvPr id="2" name="TextBox 1"/>
+          <p:cNvSpPr txBox="1"/>
+          <p:nvPr/>
+        </p:nvSpPr>
+        <p:spPr>
+          <a:xfrm>
+            <a:off x="365760" y="274320"/>
+            <a:ext cx="8412480" cy="731520"/>
+          </a:xfrm>
+          <a:prstGeom prst="rect">
+            <a:avLst/>
+          </a:prstGeom>
+          <a:noFill/>
+        </p:spPr>
+        <p:txBody>
+          <a:bodyPr wrap="none">
+            <a:spAutoFit/>
+          </a:bodyPr>
+          <a:lstStyle/>
+          <a:p>
+            <a:pPr>
+              <a:defRPr sz="2800" b="1">
+                <a:solidFill>
+                  <a:srgbClr val="062F46"/>
+                </a:solidFill>
+                <a:latin typeface="Calibri"/>
+              </a:defRPr>
+            </a:pPr>
+            <a:r>
+              <a:t>Slide 10</a:t>
+            </a:r>
+          </a:p>
+        </p:txBody>
+      </p:sp>
+      <p:sp>
+        <p:nvSpPr>
+          <p:cNvPr id="3" name="TextBox 2"/>
+          <p:cNvSpPr txBox="1"/>
+          <p:nvPr/>
+        </p:nvSpPr>
+        <p:spPr>
+          <a:xfrm>
+            <a:off x="365760" y="1097280"/>
+            <a:ext cx="8412480" cy="3291840"/>
+          </a:xfrm>
+          <a:prstGeom prst="rect">
+            <a:avLst/>
+          </a:prstGeom>
+          <a:noFill/>
+        </p:spPr>
+        <p:txBody>
+          <a:bodyPr wrap="square">
+            <a:spAutoFit/>
+          </a:bodyPr>
+          <a:lstStyle/>
+          <a:p>
+            <a:pPr>
+              <a:defRPr sz="1800">
+                <a:solidFill>
+                  <a:srgbClr val="141414"/>
+                </a:solidFill>
+                <a:latin typeface="Calibri"/>
+              </a:defRPr>
             </a:pPr>
             <a:r>
               <a:t>Slide 10 — Typical outputs &amp; audit files</a:t>
@@ -3232,7 +4801,12 @@
           </a:p>
           <a:p>
             <a:pPr>
-              <a:defRPr sz="1800"/>
+              <a:defRPr sz="1800">
+                <a:solidFill>
+                  <a:srgbClr val="141414"/>
+                </a:solidFill>
+                <a:latin typeface="Calibri"/>
+              </a:defRPr>
             </a:pPr>
             <a:r>
               <a:t>all_subjects_features.csv, features_xy.npz, classification_results.csv</a:t>
@@ -3240,7 +4814,12 @@
           </a:p>
           <a:p>
             <a:pPr>
-              <a:defRPr sz="1800"/>
+              <a:defRPr sz="1800">
+                <a:solidFill>
+                  <a:srgbClr val="141414"/>
+                </a:solidFill>
+                <a:latin typeface="Calibri"/>
+              </a:defRPr>
             </a:pPr>
             <a:r>
               <a:t>per_subject_accuracy.csv, subject_summary.csv</a:t>
@@ -3248,7 +4827,12 @@
           </a:p>
           <a:p>
             <a:pPr>
-              <a:defRPr sz="1800"/>
+              <a:defRPr sz="1800">
+                <a:solidFill>
+                  <a:srgbClr val="141414"/>
+                </a:solidFill>
+                <a:latin typeface="Calibri"/>
+              </a:defRPr>
             </a:pPr>
             <a:r>
               <a:t>biomarker_exploration_screening.csv, biomarker_loso_ablation_results.csv</a:t>
@@ -3256,7 +4840,12 @@
           </a:p>
           <a:p>
             <a:pPr>
-              <a:defRPr sz="1800"/>
+              <a:defRPr sz="1800">
+                <a:solidFill>
+                  <a:srgbClr val="141414"/>
+                </a:solidFill>
+                <a:latin typeface="Calibri"/>
+              </a:defRPr>
             </a:pPr>
             <a:r>
               <a:t>Figures: ROC curves, feature heatmaps, per-subject violin plots</a:t>
@@ -3275,6 +4864,14 @@
 <file path=ppt/slides/slide11.xml><?xml version="1.0" encoding="utf-8"?>
 <p:sld xmlns:a="http://schemas.openxmlformats.org/drawingml/2006/main" xmlns:p="http://schemas.openxmlformats.org/presentationml/2006/main" xmlns:r="http://schemas.openxmlformats.org/officeDocument/2006/relationships">
   <p:cSld>
+    <p:bg>
+      <p:bgPr>
+        <a:solidFill>
+          <a:srgbClr val="F5F7FA"/>
+        </a:solidFill>
+        <a:effectLst/>
+      </p:bgPr>
+    </p:bg>
     <p:spTree>
       <p:nvGrpSpPr>
         <p:cNvPr id="1" name=""/>
@@ -3284,42 +4881,69 @@
       <p:grpSpPr/>
       <p:sp>
         <p:nvSpPr>
-          <p:cNvPr id="2" name="Title 1"/>
-          <p:cNvSpPr>
-            <a:spLocks noGrp="1"/>
-          </p:cNvSpPr>
-          <p:nvPr>
-            <p:ph type="title"/>
-          </p:nvPr>
-        </p:nvSpPr>
-        <p:spPr/>
-        <p:txBody>
-          <a:bodyPr/>
-          <a:lstStyle/>
-          <a:p>
-            <a:r>
-              <a:t>Slide</a:t>
-            </a:r>
-          </a:p>
-        </p:txBody>
-      </p:sp>
-      <p:sp>
-        <p:nvSpPr>
-          <p:cNvPr id="3" name="Content Placeholder 2"/>
-          <p:cNvSpPr>
-            <a:spLocks noGrp="1"/>
-          </p:cNvSpPr>
-          <p:nvPr>
-            <p:ph idx="1"/>
-          </p:nvPr>
-        </p:nvSpPr>
-        <p:spPr/>
-        <p:txBody>
-          <a:bodyPr/>
-          <a:lstStyle/>
-          <a:p>
-            <a:pPr>
-              <a:defRPr sz="1800"/>
+          <p:cNvPr id="2" name="TextBox 1"/>
+          <p:cNvSpPr txBox="1"/>
+          <p:nvPr/>
+        </p:nvSpPr>
+        <p:spPr>
+          <a:xfrm>
+            <a:off x="365760" y="274320"/>
+            <a:ext cx="8412480" cy="731520"/>
+          </a:xfrm>
+          <a:prstGeom prst="rect">
+            <a:avLst/>
+          </a:prstGeom>
+          <a:noFill/>
+        </p:spPr>
+        <p:txBody>
+          <a:bodyPr wrap="none">
+            <a:spAutoFit/>
+          </a:bodyPr>
+          <a:lstStyle/>
+          <a:p>
+            <a:pPr>
+              <a:defRPr sz="2800" b="1">
+                <a:solidFill>
+                  <a:srgbClr val="062F46"/>
+                </a:solidFill>
+                <a:latin typeface="Calibri"/>
+              </a:defRPr>
+            </a:pPr>
+            <a:r>
+              <a:t>Slide 11</a:t>
+            </a:r>
+          </a:p>
+        </p:txBody>
+      </p:sp>
+      <p:sp>
+        <p:nvSpPr>
+          <p:cNvPr id="3" name="TextBox 2"/>
+          <p:cNvSpPr txBox="1"/>
+          <p:nvPr/>
+        </p:nvSpPr>
+        <p:spPr>
+          <a:xfrm>
+            <a:off x="365760" y="1097280"/>
+            <a:ext cx="8412480" cy="3291840"/>
+          </a:xfrm>
+          <a:prstGeom prst="rect">
+            <a:avLst/>
+          </a:prstGeom>
+          <a:noFill/>
+        </p:spPr>
+        <p:txBody>
+          <a:bodyPr wrap="square">
+            <a:spAutoFit/>
+          </a:bodyPr>
+          <a:lstStyle/>
+          <a:p>
+            <a:pPr>
+              <a:defRPr sz="1800">
+                <a:solidFill>
+                  <a:srgbClr val="141414"/>
+                </a:solidFill>
+                <a:latin typeface="Calibri"/>
+              </a:defRPr>
             </a:pPr>
             <a:r>
               <a:t>Slide 11 — Action items for a new dataset</a:t>
@@ -3327,7 +4951,12 @@
           </a:p>
           <a:p>
             <a:pPr>
-              <a:defRPr sz="1800"/>
+              <a:defRPr sz="1800">
+                <a:solidFill>
+                  <a:srgbClr val="141414"/>
+                </a:solidFill>
+                <a:latin typeface="Calibri"/>
+              </a:defRPr>
             </a:pPr>
             <a:r>
               <a:t>Prepare channels.tsv; verify event structure and stimulus timing</a:t>
@@ -3335,7 +4964,12 @@
           </a:p>
           <a:p>
             <a:pPr>
-              <a:defRPr sz="1800"/>
+              <a:defRPr sz="1800">
+                <a:solidFill>
+                  <a:srgbClr val="141414"/>
+                </a:solidFill>
+                <a:latin typeface="Calibri"/>
+              </a:defRPr>
             </a:pPr>
             <a:r>
               <a:t>Run preprocessing; save QC; extract baseline 135 features</a:t>
@@ -3343,7 +4977,12 @@
           </a:p>
           <a:p>
             <a:pPr>
-              <a:defRPr sz="1800"/>
+              <a:defRPr sz="1800">
+                <a:solidFill>
+                  <a:srgbClr val="141414"/>
+                </a:solidFill>
+                <a:latin typeface="Calibri"/>
+              </a:defRPr>
             </a:pPr>
             <a:r>
               <a:t>Run LOSO with training-only scaling &amp; selection; run family ablations</a:t>
@@ -3351,7 +4990,12 @@
           </a:p>
           <a:p>
             <a:pPr>
-              <a:defRPr sz="1800"/>
+              <a:defRPr sz="1800">
+                <a:solidFill>
+                  <a:srgbClr val="141414"/>
+                </a:solidFill>
+                <a:latin typeface="Calibri"/>
+              </a:defRPr>
             </a:pPr>
             <a:r>
               <a:t>If stable biomarkers appear, retrain compact model for deployment; validate on external dataset if available</a:t>
@@ -3370,6 +5014,14 @@
 <file path=ppt/slides/slide12.xml><?xml version="1.0" encoding="utf-8"?>
 <p:sld xmlns:a="http://schemas.openxmlformats.org/drawingml/2006/main" xmlns:p="http://schemas.openxmlformats.org/presentationml/2006/main" xmlns:r="http://schemas.openxmlformats.org/officeDocument/2006/relationships">
   <p:cSld>
+    <p:bg>
+      <p:bgPr>
+        <a:solidFill>
+          <a:srgbClr val="F5F7FA"/>
+        </a:solidFill>
+        <a:effectLst/>
+      </p:bgPr>
+    </p:bg>
     <p:spTree>
       <p:nvGrpSpPr>
         <p:cNvPr id="1" name=""/>
@@ -3379,42 +5031,69 @@
       <p:grpSpPr/>
       <p:sp>
         <p:nvSpPr>
-          <p:cNvPr id="2" name="Title 1"/>
-          <p:cNvSpPr>
-            <a:spLocks noGrp="1"/>
-          </p:cNvSpPr>
-          <p:nvPr>
-            <p:ph type="title"/>
-          </p:nvPr>
-        </p:nvSpPr>
-        <p:spPr/>
-        <p:txBody>
-          <a:bodyPr/>
-          <a:lstStyle/>
-          <a:p>
-            <a:r>
-              <a:t>Slide</a:t>
-            </a:r>
-          </a:p>
-        </p:txBody>
-      </p:sp>
-      <p:sp>
-        <p:nvSpPr>
-          <p:cNvPr id="3" name="Content Placeholder 2"/>
-          <p:cNvSpPr>
-            <a:spLocks noGrp="1"/>
-          </p:cNvSpPr>
-          <p:nvPr>
-            <p:ph idx="1"/>
-          </p:nvPr>
-        </p:nvSpPr>
-        <p:spPr/>
-        <p:txBody>
-          <a:bodyPr/>
-          <a:lstStyle/>
-          <a:p>
-            <a:pPr>
-              <a:defRPr sz="1800"/>
+          <p:cNvPr id="2" name="TextBox 1"/>
+          <p:cNvSpPr txBox="1"/>
+          <p:nvPr/>
+        </p:nvSpPr>
+        <p:spPr>
+          <a:xfrm>
+            <a:off x="365760" y="274320"/>
+            <a:ext cx="8412480" cy="731520"/>
+          </a:xfrm>
+          <a:prstGeom prst="rect">
+            <a:avLst/>
+          </a:prstGeom>
+          <a:noFill/>
+        </p:spPr>
+        <p:txBody>
+          <a:bodyPr wrap="none">
+            <a:spAutoFit/>
+          </a:bodyPr>
+          <a:lstStyle/>
+          <a:p>
+            <a:pPr>
+              <a:defRPr sz="2800" b="1">
+                <a:solidFill>
+                  <a:srgbClr val="062F46"/>
+                </a:solidFill>
+                <a:latin typeface="Calibri"/>
+              </a:defRPr>
+            </a:pPr>
+            <a:r>
+              <a:t>Slide 12</a:t>
+            </a:r>
+          </a:p>
+        </p:txBody>
+      </p:sp>
+      <p:sp>
+        <p:nvSpPr>
+          <p:cNvPr id="3" name="TextBox 2"/>
+          <p:cNvSpPr txBox="1"/>
+          <p:nvPr/>
+        </p:nvSpPr>
+        <p:spPr>
+          <a:xfrm>
+            <a:off x="365760" y="1097280"/>
+            <a:ext cx="8412480" cy="3291840"/>
+          </a:xfrm>
+          <a:prstGeom prst="rect">
+            <a:avLst/>
+          </a:prstGeom>
+          <a:noFill/>
+        </p:spPr>
+        <p:txBody>
+          <a:bodyPr wrap="square">
+            <a:spAutoFit/>
+          </a:bodyPr>
+          <a:lstStyle/>
+          <a:p>
+            <a:pPr>
+              <a:defRPr sz="1800">
+                <a:solidFill>
+                  <a:srgbClr val="141414"/>
+                </a:solidFill>
+                <a:latin typeface="Calibri"/>
+              </a:defRPr>
             </a:pPr>
             <a:r>
               <a:t>Slide 12 — Contact / Next steps</a:t>
@@ -3422,7 +5101,12 @@
           </a:p>
           <a:p>
             <a:pPr>
-              <a:defRPr sz="1800"/>
+              <a:defRPr sz="1800">
+                <a:solidFill>
+                  <a:srgbClr val="141414"/>
+                </a:solidFill>
+                <a:latin typeface="Calibri"/>
+              </a:defRPr>
             </a:pPr>
             <a:r>
               <a:t>Commit run outputs and config JSON for every experiment</a:t>
@@ -3430,7 +5114,12 @@
           </a:p>
           <a:p>
             <a:pPr>
-              <a:defRPr sz="1800"/>
+              <a:defRPr sz="1800">
+                <a:solidFill>
+                  <a:srgbClr val="141414"/>
+                </a:solidFill>
+                <a:latin typeface="Calibri"/>
+              </a:defRPr>
             </a:pPr>
             <a:r>
               <a:t>Add subject-level QC thresholds and automated gating</a:t>
@@ -3438,7 +5127,12 @@
           </a:p>
           <a:p>
             <a:pPr>
-              <a:defRPr sz="1800"/>
+              <a:defRPr sz="1800">
+                <a:solidFill>
+                  <a:srgbClr val="141414"/>
+                </a:solidFill>
+                <a:latin typeface="Calibri"/>
+              </a:defRPr>
             </a:pPr>
             <a:r>
               <a:t>Move toward real-time inference test with LDA on streaming ROI signals</a:t>
@@ -3457,6 +5151,14 @@
 <file path=ppt/slides/slide13.xml><?xml version="1.0" encoding="utf-8"?>
 <p:sld xmlns:a="http://schemas.openxmlformats.org/drawingml/2006/main" xmlns:p="http://schemas.openxmlformats.org/presentationml/2006/main" xmlns:r="http://schemas.openxmlformats.org/officeDocument/2006/relationships">
   <p:cSld>
+    <p:bg>
+      <p:bgPr>
+        <a:solidFill>
+          <a:srgbClr val="F5F7FA"/>
+        </a:solidFill>
+        <a:effectLst/>
+      </p:bgPr>
+    </p:bg>
     <p:spTree>
       <p:nvGrpSpPr>
         <p:cNvPr id="1" name=""/>
@@ -3466,38 +5168,60 @@
       <p:grpSpPr/>
       <p:sp>
         <p:nvSpPr>
-          <p:cNvPr id="2" name="Title 1"/>
-          <p:cNvSpPr>
-            <a:spLocks noGrp="1"/>
-          </p:cNvSpPr>
-          <p:nvPr>
-            <p:ph type="title"/>
-          </p:nvPr>
-        </p:nvSpPr>
-        <p:spPr/>
-        <p:txBody>
-          <a:bodyPr/>
-          <a:lstStyle/>
-          <a:p>
-            <a:r>
-              <a:t>Slide</a:t>
-            </a:r>
-          </a:p>
-        </p:txBody>
-      </p:sp>
-      <p:sp>
-        <p:nvSpPr>
-          <p:cNvPr id="3" name="Content Placeholder 2"/>
-          <p:cNvSpPr>
-            <a:spLocks noGrp="1"/>
-          </p:cNvSpPr>
-          <p:nvPr>
-            <p:ph idx="1"/>
-          </p:nvPr>
-        </p:nvSpPr>
-        <p:spPr/>
-        <p:txBody>
-          <a:bodyPr/>
+          <p:cNvPr id="2" name="TextBox 1"/>
+          <p:cNvSpPr txBox="1"/>
+          <p:nvPr/>
+        </p:nvSpPr>
+        <p:spPr>
+          <a:xfrm>
+            <a:off x="365760" y="274320"/>
+            <a:ext cx="8412480" cy="731520"/>
+          </a:xfrm>
+          <a:prstGeom prst="rect">
+            <a:avLst/>
+          </a:prstGeom>
+          <a:noFill/>
+        </p:spPr>
+        <p:txBody>
+          <a:bodyPr wrap="none">
+            <a:spAutoFit/>
+          </a:bodyPr>
+          <a:lstStyle/>
+          <a:p>
+            <a:pPr>
+              <a:defRPr sz="2800" b="1">
+                <a:solidFill>
+                  <a:srgbClr val="062F46"/>
+                </a:solidFill>
+                <a:latin typeface="Calibri"/>
+              </a:defRPr>
+            </a:pPr>
+            <a:r>
+              <a:t>Slide 13</a:t>
+            </a:r>
+          </a:p>
+        </p:txBody>
+      </p:sp>
+      <p:sp>
+        <p:nvSpPr>
+          <p:cNvPr id="3" name="TextBox 2"/>
+          <p:cNvSpPr txBox="1"/>
+          <p:nvPr/>
+        </p:nvSpPr>
+        <p:spPr>
+          <a:xfrm>
+            <a:off x="365760" y="1097280"/>
+            <a:ext cx="8412480" cy="3291840"/>
+          </a:xfrm>
+          <a:prstGeom prst="rect">
+            <a:avLst/>
+          </a:prstGeom>
+          <a:noFill/>
+        </p:spPr>
+        <p:txBody>
+          <a:bodyPr wrap="square">
+            <a:spAutoFit/>
+          </a:bodyPr>
           <a:lstStyle/>
           <a:p/>
         </p:txBody>
@@ -3513,6 +5237,14 @@
 <file path=ppt/slides/slide2.xml><?xml version="1.0" encoding="utf-8"?>
 <p:sld xmlns:a="http://schemas.openxmlformats.org/drawingml/2006/main" xmlns:p="http://schemas.openxmlformats.org/presentationml/2006/main" xmlns:r="http://schemas.openxmlformats.org/officeDocument/2006/relationships">
   <p:cSld>
+    <p:bg>
+      <p:bgPr>
+        <a:solidFill>
+          <a:srgbClr val="F5F7FA"/>
+        </a:solidFill>
+        <a:effectLst/>
+      </p:bgPr>
+    </p:bg>
     <p:spTree>
       <p:nvGrpSpPr>
         <p:cNvPr id="1" name=""/>
@@ -3522,42 +5254,69 @@
       <p:grpSpPr/>
       <p:sp>
         <p:nvSpPr>
-          <p:cNvPr id="2" name="Title 1"/>
-          <p:cNvSpPr>
-            <a:spLocks noGrp="1"/>
-          </p:cNvSpPr>
-          <p:nvPr>
-            <p:ph type="title"/>
-          </p:nvPr>
-        </p:nvSpPr>
-        <p:spPr/>
-        <p:txBody>
-          <a:bodyPr/>
-          <a:lstStyle/>
-          <a:p>
-            <a:r>
-              <a:t>Slide</a:t>
-            </a:r>
-          </a:p>
-        </p:txBody>
-      </p:sp>
-      <p:sp>
-        <p:nvSpPr>
-          <p:cNvPr id="3" name="Content Placeholder 2"/>
-          <p:cNvSpPr>
-            <a:spLocks noGrp="1"/>
-          </p:cNvSpPr>
-          <p:nvPr>
-            <p:ph idx="1"/>
-          </p:nvPr>
-        </p:nvSpPr>
-        <p:spPr/>
-        <p:txBody>
-          <a:bodyPr/>
-          <a:lstStyle/>
-          <a:p>
-            <a:pPr>
-              <a:defRPr sz="1800"/>
+          <p:cNvPr id="2" name="TextBox 1"/>
+          <p:cNvSpPr txBox="1"/>
+          <p:nvPr/>
+        </p:nvSpPr>
+        <p:spPr>
+          <a:xfrm>
+            <a:off x="365760" y="274320"/>
+            <a:ext cx="8412480" cy="731520"/>
+          </a:xfrm>
+          <a:prstGeom prst="rect">
+            <a:avLst/>
+          </a:prstGeom>
+          <a:noFill/>
+        </p:spPr>
+        <p:txBody>
+          <a:bodyPr wrap="none">
+            <a:spAutoFit/>
+          </a:bodyPr>
+          <a:lstStyle/>
+          <a:p>
+            <a:pPr>
+              <a:defRPr sz="2800" b="1">
+                <a:solidFill>
+                  <a:srgbClr val="062F46"/>
+                </a:solidFill>
+                <a:latin typeface="Calibri"/>
+              </a:defRPr>
+            </a:pPr>
+            <a:r>
+              <a:t>Slide 2</a:t>
+            </a:r>
+          </a:p>
+        </p:txBody>
+      </p:sp>
+      <p:sp>
+        <p:nvSpPr>
+          <p:cNvPr id="3" name="TextBox 2"/>
+          <p:cNvSpPr txBox="1"/>
+          <p:nvPr/>
+        </p:nvSpPr>
+        <p:spPr>
+          <a:xfrm>
+            <a:off x="365760" y="1097280"/>
+            <a:ext cx="8412480" cy="3291840"/>
+          </a:xfrm>
+          <a:prstGeom prst="rect">
+            <a:avLst/>
+          </a:prstGeom>
+          <a:noFill/>
+        </p:spPr>
+        <p:txBody>
+          <a:bodyPr wrap="square">
+            <a:spAutoFit/>
+          </a:bodyPr>
+          <a:lstStyle/>
+          <a:p>
+            <a:pPr>
+              <a:defRPr sz="1800">
+                <a:solidFill>
+                  <a:srgbClr val="141414"/>
+                </a:solidFill>
+                <a:latin typeface="Calibri"/>
+              </a:defRPr>
             </a:pPr>
             <a:r>
               <a:t>Slide 2 — Goals</a:t>
@@ -3565,7 +5324,12 @@
           </a:p>
           <a:p>
             <a:pPr>
-              <a:defRPr sz="1800"/>
+              <a:defRPr sz="1800">
+                <a:solidFill>
+                  <a:srgbClr val="141414"/>
+                </a:solidFill>
+                <a:latin typeface="Calibri"/>
+              </a:defRPr>
             </a:pPr>
             <a:r>
               <a:t>Identify robust EEG biomarkers that discriminate pain vs no‑pain</a:t>
@@ -3573,7 +5337,12 @@
           </a:p>
           <a:p>
             <a:pPr>
-              <a:defRPr sz="1800"/>
+              <a:defRPr sz="1800">
+                <a:solidFill>
+                  <a:srgbClr val="141414"/>
+                </a:solidFill>
+                <a:latin typeface="Calibri"/>
+              </a:defRPr>
             </a:pPr>
             <a:r>
               <a:t>Produce leakage-safe held‑out validation (LOSO)</a:t>
@@ -3581,7 +5350,12 @@
           </a:p>
           <a:p>
             <a:pPr>
-              <a:defRPr sz="1800"/>
+              <a:defRPr sz="1800">
+                <a:solidFill>
+                  <a:srgbClr val="141414"/>
+                </a:solidFill>
+                <a:latin typeface="Calibri"/>
+              </a:defRPr>
             </a:pPr>
             <a:r>
               <a:t>Provide a deployable, interpretable model and an audit trail for reproducibility</a:t>
@@ -3600,6 +5374,14 @@
 <file path=ppt/slides/slide3.xml><?xml version="1.0" encoding="utf-8"?>
 <p:sld xmlns:a="http://schemas.openxmlformats.org/drawingml/2006/main" xmlns:p="http://schemas.openxmlformats.org/presentationml/2006/main" xmlns:r="http://schemas.openxmlformats.org/officeDocument/2006/relationships">
   <p:cSld>
+    <p:bg>
+      <p:bgPr>
+        <a:solidFill>
+          <a:srgbClr val="F5F7FA"/>
+        </a:solidFill>
+        <a:effectLst/>
+      </p:bgPr>
+    </p:bg>
     <p:spTree>
       <p:nvGrpSpPr>
         <p:cNvPr id="1" name=""/>
@@ -3609,42 +5391,69 @@
       <p:grpSpPr/>
       <p:sp>
         <p:nvSpPr>
-          <p:cNvPr id="2" name="Title 1"/>
-          <p:cNvSpPr>
-            <a:spLocks noGrp="1"/>
-          </p:cNvSpPr>
-          <p:nvPr>
-            <p:ph type="title"/>
-          </p:nvPr>
-        </p:nvSpPr>
-        <p:spPr/>
-        <p:txBody>
-          <a:bodyPr/>
-          <a:lstStyle/>
-          <a:p>
-            <a:r>
-              <a:t>Slide</a:t>
-            </a:r>
-          </a:p>
-        </p:txBody>
-      </p:sp>
-      <p:sp>
-        <p:nvSpPr>
-          <p:cNvPr id="3" name="Content Placeholder 2"/>
-          <p:cNvSpPr>
-            <a:spLocks noGrp="1"/>
-          </p:cNvSpPr>
-          <p:nvPr>
-            <p:ph idx="1"/>
-          </p:nvPr>
-        </p:nvSpPr>
-        <p:spPr/>
-        <p:txBody>
-          <a:bodyPr/>
-          <a:lstStyle/>
-          <a:p>
-            <a:pPr>
-              <a:defRPr sz="1800"/>
+          <p:cNvPr id="2" name="TextBox 1"/>
+          <p:cNvSpPr txBox="1"/>
+          <p:nvPr/>
+        </p:nvSpPr>
+        <p:spPr>
+          <a:xfrm>
+            <a:off x="365760" y="274320"/>
+            <a:ext cx="8412480" cy="731520"/>
+          </a:xfrm>
+          <a:prstGeom prst="rect">
+            <a:avLst/>
+          </a:prstGeom>
+          <a:noFill/>
+        </p:spPr>
+        <p:txBody>
+          <a:bodyPr wrap="none">
+            <a:spAutoFit/>
+          </a:bodyPr>
+          <a:lstStyle/>
+          <a:p>
+            <a:pPr>
+              <a:defRPr sz="2800" b="1">
+                <a:solidFill>
+                  <a:srgbClr val="062F46"/>
+                </a:solidFill>
+                <a:latin typeface="Calibri"/>
+              </a:defRPr>
+            </a:pPr>
+            <a:r>
+              <a:t>Slide 3</a:t>
+            </a:r>
+          </a:p>
+        </p:txBody>
+      </p:sp>
+      <p:sp>
+        <p:nvSpPr>
+          <p:cNvPr id="3" name="TextBox 2"/>
+          <p:cNvSpPr txBox="1"/>
+          <p:nvPr/>
+        </p:nvSpPr>
+        <p:spPr>
+          <a:xfrm>
+            <a:off x="365760" y="1097280"/>
+            <a:ext cx="8412480" cy="3291840"/>
+          </a:xfrm>
+          <a:prstGeom prst="rect">
+            <a:avLst/>
+          </a:prstGeom>
+          <a:noFill/>
+        </p:spPr>
+        <p:txBody>
+          <a:bodyPr wrap="square">
+            <a:spAutoFit/>
+          </a:bodyPr>
+          <a:lstStyle/>
+          <a:p>
+            <a:pPr>
+              <a:defRPr sz="1800">
+                <a:solidFill>
+                  <a:srgbClr val="141414"/>
+                </a:solidFill>
+                <a:latin typeface="Calibri"/>
+              </a:defRPr>
             </a:pPr>
             <a:r>
               <a:t>Slide 3 — Dataset &amp; Key facts</a:t>
@@ -3652,7 +5461,12 @@
           </a:p>
           <a:p>
             <a:pPr>
-              <a:defRPr sz="1800"/>
+              <a:defRPr sz="1800">
+                <a:solidFill>
+                  <a:srgbClr val="141414"/>
+                </a:solidFill>
+                <a:latin typeface="Calibri"/>
+              </a:defRPr>
             </a:pPr>
             <a:r>
               <a:t>OpenNeuro ds005284 (Zhao et al.), Biosemi 64-channel, 1024 Hz (resampled to 256 Hz)</a:t>
@@ -3660,7 +5474,12 @@
           </a:p>
           <a:p>
             <a:pPr>
-              <a:defRPr sz="1800"/>
+              <a:defRPr sz="1800">
+                <a:solidFill>
+                  <a:srgbClr val="141414"/>
+                </a:solidFill>
+                <a:latin typeface="Calibri"/>
+              </a:defRPr>
             </a:pPr>
             <a:r>
               <a:t>26 subjects, 781 epochs (367 pain / 414 no‑pain)</a:t>
@@ -3668,7 +5487,12 @@
           </a:p>
           <a:p>
             <a:pPr>
-              <a:defRPr sz="1800"/>
+              <a:defRPr sz="1800">
+                <a:solidFill>
+                  <a:srgbClr val="141414"/>
+                </a:solidFill>
+                <a:latin typeface="Calibri"/>
+              </a:defRPr>
             </a:pPr>
             <a:r>
               <a:t>ROI: C3, CZ, C4 focused on somatosensory responses</a:t>
@@ -3687,6 +5511,14 @@
 <file path=ppt/slides/slide4.xml><?xml version="1.0" encoding="utf-8"?>
 <p:sld xmlns:a="http://schemas.openxmlformats.org/drawingml/2006/main" xmlns:p="http://schemas.openxmlformats.org/presentationml/2006/main" xmlns:r="http://schemas.openxmlformats.org/officeDocument/2006/relationships">
   <p:cSld>
+    <p:bg>
+      <p:bgPr>
+        <a:solidFill>
+          <a:srgbClr val="F5F7FA"/>
+        </a:solidFill>
+        <a:effectLst/>
+      </p:bgPr>
+    </p:bg>
     <p:spTree>
       <p:nvGrpSpPr>
         <p:cNvPr id="1" name=""/>
@@ -3696,42 +5528,69 @@
       <p:grpSpPr/>
       <p:sp>
         <p:nvSpPr>
-          <p:cNvPr id="2" name="Title 1"/>
-          <p:cNvSpPr>
-            <a:spLocks noGrp="1"/>
-          </p:cNvSpPr>
-          <p:nvPr>
-            <p:ph type="title"/>
-          </p:nvPr>
-        </p:nvSpPr>
-        <p:spPr/>
-        <p:txBody>
-          <a:bodyPr/>
-          <a:lstStyle/>
-          <a:p>
-            <a:r>
-              <a:t>Slide</a:t>
-            </a:r>
-          </a:p>
-        </p:txBody>
-      </p:sp>
-      <p:sp>
-        <p:nvSpPr>
-          <p:cNvPr id="3" name="Content Placeholder 2"/>
-          <p:cNvSpPr>
-            <a:spLocks noGrp="1"/>
-          </p:cNvSpPr>
-          <p:nvPr>
-            <p:ph idx="1"/>
-          </p:nvPr>
-        </p:nvSpPr>
-        <p:spPr/>
-        <p:txBody>
-          <a:bodyPr/>
-          <a:lstStyle/>
-          <a:p>
-            <a:pPr>
-              <a:defRPr sz="1800"/>
+          <p:cNvPr id="2" name="TextBox 1"/>
+          <p:cNvSpPr txBox="1"/>
+          <p:nvPr/>
+        </p:nvSpPr>
+        <p:spPr>
+          <a:xfrm>
+            <a:off x="365760" y="274320"/>
+            <a:ext cx="8412480" cy="731520"/>
+          </a:xfrm>
+          <a:prstGeom prst="rect">
+            <a:avLst/>
+          </a:prstGeom>
+          <a:noFill/>
+        </p:spPr>
+        <p:txBody>
+          <a:bodyPr wrap="none">
+            <a:spAutoFit/>
+          </a:bodyPr>
+          <a:lstStyle/>
+          <a:p>
+            <a:pPr>
+              <a:defRPr sz="2800" b="1">
+                <a:solidFill>
+                  <a:srgbClr val="062F46"/>
+                </a:solidFill>
+                <a:latin typeface="Calibri"/>
+              </a:defRPr>
+            </a:pPr>
+            <a:r>
+              <a:t>Slide 4</a:t>
+            </a:r>
+          </a:p>
+        </p:txBody>
+      </p:sp>
+      <p:sp>
+        <p:nvSpPr>
+          <p:cNvPr id="3" name="TextBox 2"/>
+          <p:cNvSpPr txBox="1"/>
+          <p:nvPr/>
+        </p:nvSpPr>
+        <p:spPr>
+          <a:xfrm>
+            <a:off x="365760" y="1097280"/>
+            <a:ext cx="8412480" cy="3291840"/>
+          </a:xfrm>
+          <a:prstGeom prst="rect">
+            <a:avLst/>
+          </a:prstGeom>
+          <a:noFill/>
+        </p:spPr>
+        <p:txBody>
+          <a:bodyPr wrap="square">
+            <a:spAutoFit/>
+          </a:bodyPr>
+          <a:lstStyle/>
+          <a:p>
+            <a:pPr>
+              <a:defRPr sz="1800">
+                <a:solidFill>
+                  <a:srgbClr val="141414"/>
+                </a:solidFill>
+                <a:latin typeface="Calibri"/>
+              </a:defRPr>
             </a:pPr>
             <a:r>
               <a:t>Slide 4 — Preprocessing pipeline (exact steps)</a:t>
@@ -3739,7 +5598,12 @@
           </a:p>
           <a:p>
             <a:pPr>
-              <a:defRPr sz="1800"/>
+              <a:defRPr sz="1800">
+                <a:solidFill>
+                  <a:srgbClr val="141414"/>
+                </a:solidFill>
+                <a:latin typeface="Calibri"/>
+              </a:defRPr>
             </a:pPr>
             <a:r>
               <a:t>1. Channel mapping: map raw device labels → 10–20 (channels.tsv)</a:t>
@@ -3747,7 +5611,12 @@
           </a:p>
           <a:p>
             <a:pPr>
-              <a:defRPr sz="1800"/>
+              <a:defRPr sz="1800">
+                <a:solidFill>
+                  <a:srgbClr val="141414"/>
+                </a:solidFill>
+                <a:latin typeface="Calibri"/>
+              </a:defRPr>
             </a:pPr>
             <a:r>
               <a:t>2. Resample: 1024 → 256 Hz</a:t>
@@ -3755,7 +5624,12 @@
           </a:p>
           <a:p>
             <a:pPr>
-              <a:defRPr sz="1800"/>
+              <a:defRPr sz="1800">
+                <a:solidFill>
+                  <a:srgbClr val="141414"/>
+                </a:solidFill>
+                <a:latin typeface="Calibri"/>
+              </a:defRPr>
             </a:pPr>
             <a:r>
               <a:t>3. Notch: 50 Hz &amp; 100 Hz (adjust to 60 Hz mains if needed)</a:t>
@@ -3763,7 +5637,12 @@
           </a:p>
           <a:p>
             <a:pPr>
-              <a:defRPr sz="1800"/>
+              <a:defRPr sz="1800">
+                <a:solidFill>
+                  <a:srgbClr val="141414"/>
+                </a:solidFill>
+                <a:latin typeface="Calibri"/>
+              </a:defRPr>
             </a:pPr>
             <a:r>
               <a:t>4. Bandpass: 0.5 – 80 Hz</a:t>
@@ -3771,7 +5650,12 @@
           </a:p>
           <a:p>
             <a:pPr>
-              <a:defRPr sz="1800"/>
+              <a:defRPr sz="1800">
+                <a:solidFill>
+                  <a:srgbClr val="141414"/>
+                </a:solidFill>
+                <a:latin typeface="Calibri"/>
+              </a:defRPr>
             </a:pPr>
             <a:r>
               <a:t>5. Reference: average reference</a:t>
@@ -3779,7 +5663,12 @@
           </a:p>
           <a:p>
             <a:pPr>
-              <a:defRPr sz="1800"/>
+              <a:defRPr sz="1800">
+                <a:solidFill>
+                  <a:srgbClr val="141414"/>
+                </a:solidFill>
+                <a:latin typeface="Calibri"/>
+              </a:defRPr>
             </a:pPr>
             <a:r>
               <a:t>6. Epoching:</a:t>
@@ -3787,7 +5676,12 @@
           </a:p>
           <a:p>
             <a:pPr>
-              <a:defRPr sz="1800"/>
+              <a:defRPr sz="1800">
+                <a:solidFill>
+                  <a:srgbClr val="141414"/>
+                </a:solidFill>
+                <a:latin typeface="Calibri"/>
+              </a:defRPr>
             </a:pPr>
             <a:r>
               <a:t>Pain: 0 → +2 s relative to stimulus onset</a:t>
@@ -3795,7 +5689,12 @@
           </a:p>
           <a:p>
             <a:pPr>
-              <a:defRPr sz="1800"/>
+              <a:defRPr sz="1800">
+                <a:solidFill>
+                  <a:srgbClr val="141414"/>
+                </a:solidFill>
+                <a:latin typeface="Calibri"/>
+              </a:defRPr>
             </a:pPr>
             <a:r>
               <a:t>No‑pain baseline: −5 → −3 s</a:t>
@@ -3803,10 +5702,28 @@
           </a:p>
           <a:p>
             <a:pPr>
-              <a:defRPr sz="1800"/>
+              <a:defRPr sz="1800">
+                <a:solidFill>
+                  <a:srgbClr val="141414"/>
+                </a:solidFill>
+                <a:latin typeface="Calibri"/>
+              </a:defRPr>
             </a:pPr>
             <a:r>
               <a:t>7. Artifact rejection: amplitude threshold (|µV| &gt; 200)</a:t>
+            </a:r>
+          </a:p>
+          <a:p>
+            <a:pPr>
+              <a:defRPr sz="1800">
+                <a:solidFill>
+                  <a:srgbClr val="141414"/>
+                </a:solidFill>
+                <a:latin typeface="Calibri"/>
+              </a:defRPr>
+            </a:pPr>
+            <a:r>
+              <a:t>8. Save per-epoch QC and per-subject summaries (audit CSVs)</a:t>
             </a:r>
           </a:p>
         </p:txBody>
@@ -3822,6 +5739,14 @@
 <file path=ppt/slides/slide5.xml><?xml version="1.0" encoding="utf-8"?>
 <p:sld xmlns:a="http://schemas.openxmlformats.org/drawingml/2006/main" xmlns:p="http://schemas.openxmlformats.org/presentationml/2006/main" xmlns:r="http://schemas.openxmlformats.org/officeDocument/2006/relationships">
   <p:cSld>
+    <p:bg>
+      <p:bgPr>
+        <a:solidFill>
+          <a:srgbClr val="F5F7FA"/>
+        </a:solidFill>
+        <a:effectLst/>
+      </p:bgPr>
+    </p:bg>
     <p:spTree>
       <p:nvGrpSpPr>
         <p:cNvPr id="1" name=""/>
@@ -3831,42 +5756,69 @@
       <p:grpSpPr/>
       <p:sp>
         <p:nvSpPr>
-          <p:cNvPr id="2" name="Title 1"/>
-          <p:cNvSpPr>
-            <a:spLocks noGrp="1"/>
-          </p:cNvSpPr>
-          <p:nvPr>
-            <p:ph type="title"/>
-          </p:nvPr>
-        </p:nvSpPr>
-        <p:spPr/>
-        <p:txBody>
-          <a:bodyPr/>
-          <a:lstStyle/>
-          <a:p>
-            <a:r>
-              <a:t>Slide</a:t>
-            </a:r>
-          </a:p>
-        </p:txBody>
-      </p:sp>
-      <p:sp>
-        <p:nvSpPr>
-          <p:cNvPr id="3" name="Content Placeholder 2"/>
-          <p:cNvSpPr>
-            <a:spLocks noGrp="1"/>
-          </p:cNvSpPr>
-          <p:nvPr>
-            <p:ph idx="1"/>
-          </p:nvPr>
-        </p:nvSpPr>
-        <p:spPr/>
-        <p:txBody>
-          <a:bodyPr/>
-          <a:lstStyle/>
-          <a:p>
-            <a:pPr>
-              <a:defRPr sz="1800"/>
+          <p:cNvPr id="2" name="TextBox 1"/>
+          <p:cNvSpPr txBox="1"/>
+          <p:nvPr/>
+        </p:nvSpPr>
+        <p:spPr>
+          <a:xfrm>
+            <a:off x="365760" y="274320"/>
+            <a:ext cx="8412480" cy="731520"/>
+          </a:xfrm>
+          <a:prstGeom prst="rect">
+            <a:avLst/>
+          </a:prstGeom>
+          <a:noFill/>
+        </p:spPr>
+        <p:txBody>
+          <a:bodyPr wrap="none">
+            <a:spAutoFit/>
+          </a:bodyPr>
+          <a:lstStyle/>
+          <a:p>
+            <a:pPr>
+              <a:defRPr sz="2800" b="1">
+                <a:solidFill>
+                  <a:srgbClr val="062F46"/>
+                </a:solidFill>
+                <a:latin typeface="Calibri"/>
+              </a:defRPr>
+            </a:pPr>
+            <a:r>
+              <a:t>Slide 5</a:t>
+            </a:r>
+          </a:p>
+        </p:txBody>
+      </p:sp>
+      <p:sp>
+        <p:nvSpPr>
+          <p:cNvPr id="3" name="TextBox 2"/>
+          <p:cNvSpPr txBox="1"/>
+          <p:nvPr/>
+        </p:nvSpPr>
+        <p:spPr>
+          <a:xfrm>
+            <a:off x="365760" y="1097280"/>
+            <a:ext cx="8412480" cy="3291840"/>
+          </a:xfrm>
+          <a:prstGeom prst="rect">
+            <a:avLst/>
+          </a:prstGeom>
+          <a:noFill/>
+        </p:spPr>
+        <p:txBody>
+          <a:bodyPr wrap="square">
+            <a:spAutoFit/>
+          </a:bodyPr>
+          <a:lstStyle/>
+          <a:p>
+            <a:pPr>
+              <a:defRPr sz="1800">
+                <a:solidFill>
+                  <a:srgbClr val="141414"/>
+                </a:solidFill>
+                <a:latin typeface="Calibri"/>
+              </a:defRPr>
             </a:pPr>
             <a:r>
               <a:t>Slide 5 — Feature families (extract all for new datasets)</a:t>
@@ -3874,7 +5826,12 @@
           </a:p>
           <a:p>
             <a:pPr>
-              <a:defRPr sz="1800"/>
+              <a:defRPr sz="1800">
+                <a:solidFill>
+                  <a:srgbClr val="141414"/>
+                </a:solidFill>
+                <a:latin typeface="Calibri"/>
+              </a:defRPr>
             </a:pPr>
             <a:r>
               <a:t>Spectral: abs/rel band power (δ,θ,α,β,low‑γ), band ratios, spectral centroid, median freq, 1/f slope</a:t>
@@ -3882,7 +5839,12 @@
           </a:p>
           <a:p>
             <a:pPr>
-              <a:defRPr sz="1800"/>
+              <a:defRPr sz="1800">
+                <a:solidFill>
+                  <a:srgbClr val="141414"/>
+                </a:solidFill>
+                <a:latin typeface="Calibri"/>
+              </a:defRPr>
             </a:pPr>
             <a:r>
               <a:t>Nonlinear: Higuchi FD, Petrosian FD, DFA, sample &amp; permutation entropy, Lempel‑Ziv, Hjorth</a:t>
@@ -3890,7 +5852,12 @@
           </a:p>
           <a:p>
             <a:pPr>
-              <a:defRPr sz="1800"/>
+              <a:defRPr sz="1800">
+                <a:solidFill>
+                  <a:srgbClr val="141414"/>
+                </a:solidFill>
+                <a:latin typeface="Calibri"/>
+              </a:defRPr>
             </a:pPr>
             <a:r>
               <a:t>Time-domain: RMS, STD, peak‑to‑peak, line length, zero-crossing rate, skew, kurtosis</a:t>
@@ -3898,7 +5865,12 @@
           </a:p>
           <a:p>
             <a:pPr>
-              <a:defRPr sz="1800"/>
+              <a:defRPr sz="1800">
+                <a:solidFill>
+                  <a:srgbClr val="141414"/>
+                </a:solidFill>
+                <a:latin typeface="Calibri"/>
+              </a:defRPr>
             </a:pPr>
             <a:r>
               <a:t>Wavelet: db4 multiscale energy ratios, wavelet entropy</a:t>
@@ -3906,7 +5878,12 @@
           </a:p>
           <a:p>
             <a:pPr>
-              <a:defRPr sz="1800"/>
+              <a:defRPr sz="1800">
+                <a:solidFill>
+                  <a:srgbClr val="141414"/>
+                </a:solidFill>
+                <a:latin typeface="Calibri"/>
+              </a:defRPr>
             </a:pPr>
             <a:r>
               <a:t>MFCC: first 5 MFCC means per channel</a:t>
@@ -3914,7 +5891,12 @@
           </a:p>
           <a:p>
             <a:pPr>
-              <a:defRPr sz="1800"/>
+              <a:defRPr sz="1800">
+                <a:solidFill>
+                  <a:srgbClr val="141414"/>
+                </a:solidFill>
+                <a:latin typeface="Calibri"/>
+              </a:defRPr>
             </a:pPr>
             <a:r>
               <a:t>AR dynamics: Burg AR coefficients + innovation variance</a:t>
@@ -3922,7 +5904,12 @@
           </a:p>
           <a:p>
             <a:pPr>
-              <a:defRPr sz="1800"/>
+              <a:defRPr sz="1800">
+                <a:solidFill>
+                  <a:srgbClr val="141414"/>
+                </a:solidFill>
+                <a:latin typeface="Calibri"/>
+              </a:defRPr>
             </a:pPr>
             <a:r>
               <a:t>Connectivity: coherence &amp; PLV for C3-CZ, C3-C4, CZ-C4 across bands</a:t>
@@ -3941,6 +5928,14 @@
 <file path=ppt/slides/slide6.xml><?xml version="1.0" encoding="utf-8"?>
 <p:sld xmlns:a="http://schemas.openxmlformats.org/drawingml/2006/main" xmlns:p="http://schemas.openxmlformats.org/presentationml/2006/main" xmlns:r="http://schemas.openxmlformats.org/officeDocument/2006/relationships">
   <p:cSld>
+    <p:bg>
+      <p:bgPr>
+        <a:solidFill>
+          <a:srgbClr val="F5F7FA"/>
+        </a:solidFill>
+        <a:effectLst/>
+      </p:bgPr>
+    </p:bg>
     <p:spTree>
       <p:nvGrpSpPr>
         <p:cNvPr id="1" name=""/>
@@ -3950,42 +5945,69 @@
       <p:grpSpPr/>
       <p:sp>
         <p:nvSpPr>
-          <p:cNvPr id="2" name="Title 1"/>
-          <p:cNvSpPr>
-            <a:spLocks noGrp="1"/>
-          </p:cNvSpPr>
-          <p:nvPr>
-            <p:ph type="title"/>
-          </p:nvPr>
-        </p:nvSpPr>
-        <p:spPr/>
-        <p:txBody>
-          <a:bodyPr/>
-          <a:lstStyle/>
-          <a:p>
-            <a:r>
-              <a:t>Slide</a:t>
-            </a:r>
-          </a:p>
-        </p:txBody>
-      </p:sp>
-      <p:sp>
-        <p:nvSpPr>
-          <p:cNvPr id="3" name="Content Placeholder 2"/>
-          <p:cNvSpPr>
-            <a:spLocks noGrp="1"/>
-          </p:cNvSpPr>
-          <p:nvPr>
-            <p:ph idx="1"/>
-          </p:nvPr>
-        </p:nvSpPr>
-        <p:spPr/>
-        <p:txBody>
-          <a:bodyPr/>
-          <a:lstStyle/>
-          <a:p>
-            <a:pPr>
-              <a:defRPr sz="1800"/>
+          <p:cNvPr id="2" name="TextBox 1"/>
+          <p:cNvSpPr txBox="1"/>
+          <p:nvPr/>
+        </p:nvSpPr>
+        <p:spPr>
+          <a:xfrm>
+            <a:off x="365760" y="274320"/>
+            <a:ext cx="8412480" cy="731520"/>
+          </a:xfrm>
+          <a:prstGeom prst="rect">
+            <a:avLst/>
+          </a:prstGeom>
+          <a:noFill/>
+        </p:spPr>
+        <p:txBody>
+          <a:bodyPr wrap="none">
+            <a:spAutoFit/>
+          </a:bodyPr>
+          <a:lstStyle/>
+          <a:p>
+            <a:pPr>
+              <a:defRPr sz="2800" b="1">
+                <a:solidFill>
+                  <a:srgbClr val="062F46"/>
+                </a:solidFill>
+                <a:latin typeface="Calibri"/>
+              </a:defRPr>
+            </a:pPr>
+            <a:r>
+              <a:t>Slide 6</a:t>
+            </a:r>
+          </a:p>
+        </p:txBody>
+      </p:sp>
+      <p:sp>
+        <p:nvSpPr>
+          <p:cNvPr id="3" name="TextBox 2"/>
+          <p:cNvSpPr txBox="1"/>
+          <p:nvPr/>
+        </p:nvSpPr>
+        <p:spPr>
+          <a:xfrm>
+            <a:off x="365760" y="1097280"/>
+            <a:ext cx="8412480" cy="3291840"/>
+          </a:xfrm>
+          <a:prstGeom prst="rect">
+            <a:avLst/>
+          </a:prstGeom>
+          <a:noFill/>
+        </p:spPr>
+        <p:txBody>
+          <a:bodyPr wrap="square">
+            <a:spAutoFit/>
+          </a:bodyPr>
+          <a:lstStyle/>
+          <a:p>
+            <a:pPr>
+              <a:defRPr sz="1800">
+                <a:solidFill>
+                  <a:srgbClr val="141414"/>
+                </a:solidFill>
+                <a:latin typeface="Calibri"/>
+              </a:defRPr>
             </a:pPr>
             <a:r>
               <a:t>Slide 6 — Feature naming &amp; storage</a:t>
@@ -3993,7 +6015,12 @@
           </a:p>
           <a:p>
             <a:pPr>
-              <a:defRPr sz="1800"/>
+              <a:defRPr sz="1800">
+                <a:solidFill>
+                  <a:srgbClr val="141414"/>
+                </a:solidFill>
+                <a:latin typeface="Calibri"/>
+              </a:defRPr>
             </a:pPr>
             <a:r>
               <a:t>Use descriptive names: e.g., CZ_higuchi, C3_alpha_power, CZ_C4_lowgamma_plv</a:t>
@@ -4001,7 +6028,12 @@
           </a:p>
           <a:p>
             <a:pPr>
-              <a:defRPr sz="1800"/>
+              <a:defRPr sz="1800">
+                <a:solidFill>
+                  <a:srgbClr val="141414"/>
+                </a:solidFill>
+                <a:latin typeface="Calibri"/>
+              </a:defRPr>
             </a:pPr>
             <a:r>
               <a:t>Save:</a:t>
@@ -4009,7 +6041,12 @@
           </a:p>
           <a:p>
             <a:pPr>
-              <a:defRPr sz="1800"/>
+              <a:defRPr sz="1800">
+                <a:solidFill>
+                  <a:srgbClr val="141414"/>
+                </a:solidFill>
+                <a:latin typeface="Calibri"/>
+              </a:defRPr>
             </a:pPr>
             <a:r>
               <a:t>features CSV (rows = epochs, cols = features)</a:t>
@@ -4017,7 +6054,12 @@
           </a:p>
           <a:p>
             <a:pPr>
-              <a:defRPr sz="1800"/>
+              <a:defRPr sz="1800">
+                <a:solidFill>
+                  <a:srgbClr val="141414"/>
+                </a:solidFill>
+                <a:latin typeface="Calibri"/>
+              </a:defRPr>
             </a:pPr>
             <a:r>
               <a:t>features NPZ (X, y, subjects, feature_names)</a:t>
@@ -4025,7 +6067,12 @@
           </a:p>
           <a:p>
             <a:pPr>
-              <a:defRPr sz="1800"/>
+              <a:defRPr sz="1800">
+                <a:solidFill>
+                  <a:srgbClr val="141414"/>
+                </a:solidFill>
+                <a:latin typeface="Calibri"/>
+              </a:defRPr>
             </a:pPr>
             <a:r>
               <a:t>per-epoch QC CSV and subject_summary.csv</a:t>
@@ -4044,6 +6091,14 @@
 <file path=ppt/slides/slide7.xml><?xml version="1.0" encoding="utf-8"?>
 <p:sld xmlns:a="http://schemas.openxmlformats.org/drawingml/2006/main" xmlns:p="http://schemas.openxmlformats.org/presentationml/2006/main" xmlns:r="http://schemas.openxmlformats.org/officeDocument/2006/relationships">
   <p:cSld>
+    <p:bg>
+      <p:bgPr>
+        <a:solidFill>
+          <a:srgbClr val="F5F7FA"/>
+        </a:solidFill>
+        <a:effectLst/>
+      </p:bgPr>
+    </p:bg>
     <p:spTree>
       <p:nvGrpSpPr>
         <p:cNvPr id="1" name=""/>
@@ -4053,42 +6108,69 @@
       <p:grpSpPr/>
       <p:sp>
         <p:nvSpPr>
-          <p:cNvPr id="2" name="Title 1"/>
-          <p:cNvSpPr>
-            <a:spLocks noGrp="1"/>
-          </p:cNvSpPr>
-          <p:nvPr>
-            <p:ph type="title"/>
-          </p:nvPr>
-        </p:nvSpPr>
-        <p:spPr/>
-        <p:txBody>
-          <a:bodyPr/>
-          <a:lstStyle/>
-          <a:p>
-            <a:r>
-              <a:t>Slide</a:t>
-            </a:r>
-          </a:p>
-        </p:txBody>
-      </p:sp>
-      <p:sp>
-        <p:nvSpPr>
-          <p:cNvPr id="3" name="Content Placeholder 2"/>
-          <p:cNvSpPr>
-            <a:spLocks noGrp="1"/>
-          </p:cNvSpPr>
-          <p:nvPr>
-            <p:ph idx="1"/>
-          </p:nvPr>
-        </p:nvSpPr>
-        <p:spPr/>
-        <p:txBody>
-          <a:bodyPr/>
-          <a:lstStyle/>
-          <a:p>
-            <a:pPr>
-              <a:defRPr sz="1800"/>
+          <p:cNvPr id="2" name="TextBox 1"/>
+          <p:cNvSpPr txBox="1"/>
+          <p:nvPr/>
+        </p:nvSpPr>
+        <p:spPr>
+          <a:xfrm>
+            <a:off x="365760" y="274320"/>
+            <a:ext cx="8412480" cy="731520"/>
+          </a:xfrm>
+          <a:prstGeom prst="rect">
+            <a:avLst/>
+          </a:prstGeom>
+          <a:noFill/>
+        </p:spPr>
+        <p:txBody>
+          <a:bodyPr wrap="none">
+            <a:spAutoFit/>
+          </a:bodyPr>
+          <a:lstStyle/>
+          <a:p>
+            <a:pPr>
+              <a:defRPr sz="2800" b="1">
+                <a:solidFill>
+                  <a:srgbClr val="062F46"/>
+                </a:solidFill>
+                <a:latin typeface="Calibri"/>
+              </a:defRPr>
+            </a:pPr>
+            <a:r>
+              <a:t>Slide 7</a:t>
+            </a:r>
+          </a:p>
+        </p:txBody>
+      </p:sp>
+      <p:sp>
+        <p:nvSpPr>
+          <p:cNvPr id="3" name="TextBox 2"/>
+          <p:cNvSpPr txBox="1"/>
+          <p:nvPr/>
+        </p:nvSpPr>
+        <p:spPr>
+          <a:xfrm>
+            <a:off x="365760" y="1097280"/>
+            <a:ext cx="8412480" cy="3291840"/>
+          </a:xfrm>
+          <a:prstGeom prst="rect">
+            <a:avLst/>
+          </a:prstGeom>
+          <a:noFill/>
+        </p:spPr>
+        <p:txBody>
+          <a:bodyPr wrap="square">
+            <a:spAutoFit/>
+          </a:bodyPr>
+          <a:lstStyle/>
+          <a:p>
+            <a:pPr>
+              <a:defRPr sz="1800">
+                <a:solidFill>
+                  <a:srgbClr val="141414"/>
+                </a:solidFill>
+                <a:latin typeface="Calibri"/>
+              </a:defRPr>
             </a:pPr>
             <a:r>
               <a:t>Slide 7 — Validation (leakage-safe procedure)</a:t>
@@ -4096,7 +6178,12 @@
           </a:p>
           <a:p>
             <a:pPr>
-              <a:defRPr sz="1800"/>
+              <a:defRPr sz="1800">
+                <a:solidFill>
+                  <a:srgbClr val="141414"/>
+                </a:solidFill>
+                <a:latin typeface="Calibri"/>
+              </a:defRPr>
             </a:pPr>
             <a:r>
               <a:t>1. Use Leave‑One‑Subject‑Out (LOSO) or appropriate grouped CV</a:t>
@@ -4104,7 +6191,12 @@
           </a:p>
           <a:p>
             <a:pPr>
-              <a:defRPr sz="1800"/>
+              <a:defRPr sz="1800">
+                <a:solidFill>
+                  <a:srgbClr val="141414"/>
+                </a:solidFill>
+                <a:latin typeface="Calibri"/>
+              </a:defRPr>
             </a:pPr>
             <a:r>
               <a:t>2. For each training fold:</a:t>
@@ -4112,7 +6204,12 @@
           </a:p>
           <a:p>
             <a:pPr>
-              <a:defRPr sz="1800"/>
+              <a:defRPr sz="1800">
+                <a:solidFill>
+                  <a:srgbClr val="141414"/>
+                </a:solidFill>
+                <a:latin typeface="Calibri"/>
+              </a:defRPr>
             </a:pPr>
             <a:r>
               <a:t>Replace non-finite, apply variance threshold (train-only)</a:t>
@@ -4120,7 +6217,12 @@
           </a:p>
           <a:p>
             <a:pPr>
-              <a:defRPr sz="1800"/>
+              <a:defRPr sz="1800">
+                <a:solidFill>
+                  <a:srgbClr val="141414"/>
+                </a:solidFill>
+                <a:latin typeface="Calibri"/>
+              </a:defRPr>
             </a:pPr>
             <a:r>
               <a:t>Fit StandardScaler (train-only) → transform test</a:t>
@@ -4128,7 +6230,12 @@
           </a:p>
           <a:p>
             <a:pPr>
-              <a:defRPr sz="1800"/>
+              <a:defRPr sz="1800">
+                <a:solidFill>
+                  <a:srgbClr val="141414"/>
+                </a:solidFill>
+                <a:latin typeface="Calibri"/>
+              </a:defRPr>
             </a:pPr>
             <a:r>
               <a:t>Compute ANOVA-F ranking on train → select top‑K (e.g., K=60)</a:t>
@@ -4136,7 +6243,12 @@
           </a:p>
           <a:p>
             <a:pPr>
-              <a:defRPr sz="1800"/>
+              <a:defRPr sz="1800">
+                <a:solidFill>
+                  <a:srgbClr val="141414"/>
+                </a:solidFill>
+                <a:latin typeface="Calibri"/>
+              </a:defRPr>
             </a:pPr>
             <a:r>
               <a:t>Fit classifier (e.g., LDA with shrinkage)</a:t>
@@ -4144,7 +6256,12 @@
           </a:p>
           <a:p>
             <a:pPr>
-              <a:defRPr sz="1800"/>
+              <a:defRPr sz="1800">
+                <a:solidFill>
+                  <a:srgbClr val="141414"/>
+                </a:solidFill>
+                <a:latin typeface="Calibri"/>
+              </a:defRPr>
             </a:pPr>
             <a:r>
               <a:t>3. Predict on held‑out subject; collect per-fold AUCs, sensitivities, specificities</a:t>
@@ -4152,7 +6269,12 @@
           </a:p>
           <a:p>
             <a:pPr>
-              <a:defRPr sz="1800"/>
+              <a:defRPr sz="1800">
+                <a:solidFill>
+                  <a:srgbClr val="141414"/>
+                </a:solidFill>
+                <a:latin typeface="Calibri"/>
+              </a:defRPr>
             </a:pPr>
             <a:r>
               <a:t>4. Report mean AUC ± SD and per-subject metrics; use paired tests for ablations (Wilcoxon)</a:t>
@@ -4171,6 +6293,14 @@
 <file path=ppt/slides/slide8.xml><?xml version="1.0" encoding="utf-8"?>
 <p:sld xmlns:a="http://schemas.openxmlformats.org/drawingml/2006/main" xmlns:p="http://schemas.openxmlformats.org/presentationml/2006/main" xmlns:r="http://schemas.openxmlformats.org/officeDocument/2006/relationships">
   <p:cSld>
+    <p:bg>
+      <p:bgPr>
+        <a:solidFill>
+          <a:srgbClr val="F5F7FA"/>
+        </a:solidFill>
+        <a:effectLst/>
+      </p:bgPr>
+    </p:bg>
     <p:spTree>
       <p:nvGrpSpPr>
         <p:cNvPr id="1" name=""/>
@@ -4180,42 +6310,69 @@
       <p:grpSpPr/>
       <p:sp>
         <p:nvSpPr>
-          <p:cNvPr id="2" name="Title 1"/>
-          <p:cNvSpPr>
-            <a:spLocks noGrp="1"/>
-          </p:cNvSpPr>
-          <p:nvPr>
-            <p:ph type="title"/>
-          </p:nvPr>
-        </p:nvSpPr>
-        <p:spPr/>
-        <p:txBody>
-          <a:bodyPr/>
-          <a:lstStyle/>
-          <a:p>
-            <a:r>
-              <a:t>Slide</a:t>
-            </a:r>
-          </a:p>
-        </p:txBody>
-      </p:sp>
-      <p:sp>
-        <p:nvSpPr>
-          <p:cNvPr id="3" name="Content Placeholder 2"/>
-          <p:cNvSpPr>
-            <a:spLocks noGrp="1"/>
-          </p:cNvSpPr>
-          <p:nvPr>
-            <p:ph idx="1"/>
-          </p:nvPr>
-        </p:nvSpPr>
-        <p:spPr/>
-        <p:txBody>
-          <a:bodyPr/>
-          <a:lstStyle/>
-          <a:p>
-            <a:pPr>
-              <a:defRPr sz="1800"/>
+          <p:cNvPr id="2" name="TextBox 1"/>
+          <p:cNvSpPr txBox="1"/>
+          <p:nvPr/>
+        </p:nvSpPr>
+        <p:spPr>
+          <a:xfrm>
+            <a:off x="365760" y="274320"/>
+            <a:ext cx="8412480" cy="731520"/>
+          </a:xfrm>
+          <a:prstGeom prst="rect">
+            <a:avLst/>
+          </a:prstGeom>
+          <a:noFill/>
+        </p:spPr>
+        <p:txBody>
+          <a:bodyPr wrap="none">
+            <a:spAutoFit/>
+          </a:bodyPr>
+          <a:lstStyle/>
+          <a:p>
+            <a:pPr>
+              <a:defRPr sz="2800" b="1">
+                <a:solidFill>
+                  <a:srgbClr val="062F46"/>
+                </a:solidFill>
+                <a:latin typeface="Calibri"/>
+              </a:defRPr>
+            </a:pPr>
+            <a:r>
+              <a:t>Slide 8</a:t>
+            </a:r>
+          </a:p>
+        </p:txBody>
+      </p:sp>
+      <p:sp>
+        <p:nvSpPr>
+          <p:cNvPr id="3" name="TextBox 2"/>
+          <p:cNvSpPr txBox="1"/>
+          <p:nvPr/>
+        </p:nvSpPr>
+        <p:spPr>
+          <a:xfrm>
+            <a:off x="365760" y="1097280"/>
+            <a:ext cx="8412480" cy="3291840"/>
+          </a:xfrm>
+          <a:prstGeom prst="rect">
+            <a:avLst/>
+          </a:prstGeom>
+          <a:noFill/>
+        </p:spPr>
+        <p:txBody>
+          <a:bodyPr wrap="square">
+            <a:spAutoFit/>
+          </a:bodyPr>
+          <a:lstStyle/>
+          <a:p>
+            <a:pPr>
+              <a:defRPr sz="1800">
+                <a:solidFill>
+                  <a:srgbClr val="141414"/>
+                </a:solidFill>
+                <a:latin typeface="Calibri"/>
+              </a:defRPr>
             </a:pPr>
             <a:r>
               <a:t>Slide 8 — Recommended classifiers &amp; deployment</a:t>
@@ -4223,7 +6380,12 @@
           </a:p>
           <a:p>
             <a:pPr>
-              <a:defRPr sz="1800"/>
+              <a:defRPr sz="1800">
+                <a:solidFill>
+                  <a:srgbClr val="141414"/>
+                </a:solidFill>
+                <a:latin typeface="Calibri"/>
+              </a:defRPr>
             </a:pPr>
             <a:r>
               <a:t>Research / exploration: RF / Gradient Boosting for ablation; check overfitting</a:t>
@@ -4231,7 +6393,12 @@
           </a:p>
           <a:p>
             <a:pPr>
-              <a:defRPr sz="1800"/>
+              <a:defRPr sz="1800">
+                <a:solidFill>
+                  <a:srgbClr val="141414"/>
+                </a:solidFill>
+                <a:latin typeface="Calibri"/>
+              </a:defRPr>
             </a:pPr>
             <a:r>
               <a:t>Deployment / interpretability: LDA (shrinkage) on parsimonious set (e.g., top nonlinear CZ features)</a:t>
@@ -4239,7 +6406,12 @@
           </a:p>
           <a:p>
             <a:pPr>
-              <a:defRPr sz="1800"/>
+              <a:defRPr sz="1800">
+                <a:solidFill>
+                  <a:srgbClr val="141414"/>
+                </a:solidFill>
+                <a:latin typeface="Calibri"/>
+              </a:defRPr>
             </a:pPr>
             <a:r>
               <a:t>Implement per-subject QC gating before decision-making</a:t>
@@ -4258,6 +6430,14 @@
 <file path=ppt/slides/slide9.xml><?xml version="1.0" encoding="utf-8"?>
 <p:sld xmlns:a="http://schemas.openxmlformats.org/drawingml/2006/main" xmlns:p="http://schemas.openxmlformats.org/presentationml/2006/main" xmlns:r="http://schemas.openxmlformats.org/officeDocument/2006/relationships">
   <p:cSld>
+    <p:bg>
+      <p:bgPr>
+        <a:solidFill>
+          <a:srgbClr val="F5F7FA"/>
+        </a:solidFill>
+        <a:effectLst/>
+      </p:bgPr>
+    </p:bg>
     <p:spTree>
       <p:nvGrpSpPr>
         <p:cNvPr id="1" name=""/>
@@ -4267,42 +6447,69 @@
       <p:grpSpPr/>
       <p:sp>
         <p:nvSpPr>
-          <p:cNvPr id="2" name="Title 1"/>
-          <p:cNvSpPr>
-            <a:spLocks noGrp="1"/>
-          </p:cNvSpPr>
-          <p:nvPr>
-            <p:ph type="title"/>
-          </p:nvPr>
-        </p:nvSpPr>
-        <p:spPr/>
-        <p:txBody>
-          <a:bodyPr/>
-          <a:lstStyle/>
-          <a:p>
-            <a:r>
-              <a:t>Slide</a:t>
-            </a:r>
-          </a:p>
-        </p:txBody>
-      </p:sp>
-      <p:sp>
-        <p:nvSpPr>
-          <p:cNvPr id="3" name="Content Placeholder 2"/>
-          <p:cNvSpPr>
-            <a:spLocks noGrp="1"/>
-          </p:cNvSpPr>
-          <p:nvPr>
-            <p:ph idx="1"/>
-          </p:nvPr>
-        </p:nvSpPr>
-        <p:spPr/>
-        <p:txBody>
-          <a:bodyPr/>
-          <a:lstStyle/>
-          <a:p>
-            <a:pPr>
-              <a:defRPr sz="1800"/>
+          <p:cNvPr id="2" name="TextBox 1"/>
+          <p:cNvSpPr txBox="1"/>
+          <p:nvPr/>
+        </p:nvSpPr>
+        <p:spPr>
+          <a:xfrm>
+            <a:off x="365760" y="274320"/>
+            <a:ext cx="8412480" cy="731520"/>
+          </a:xfrm>
+          <a:prstGeom prst="rect">
+            <a:avLst/>
+          </a:prstGeom>
+          <a:noFill/>
+        </p:spPr>
+        <p:txBody>
+          <a:bodyPr wrap="none">
+            <a:spAutoFit/>
+          </a:bodyPr>
+          <a:lstStyle/>
+          <a:p>
+            <a:pPr>
+              <a:defRPr sz="2800" b="1">
+                <a:solidFill>
+                  <a:srgbClr val="062F46"/>
+                </a:solidFill>
+                <a:latin typeface="Calibri"/>
+              </a:defRPr>
+            </a:pPr>
+            <a:r>
+              <a:t>Slide 9</a:t>
+            </a:r>
+          </a:p>
+        </p:txBody>
+      </p:sp>
+      <p:sp>
+        <p:nvSpPr>
+          <p:cNvPr id="3" name="TextBox 2"/>
+          <p:cNvSpPr txBox="1"/>
+          <p:nvPr/>
+        </p:nvSpPr>
+        <p:spPr>
+          <a:xfrm>
+            <a:off x="365760" y="1097280"/>
+            <a:ext cx="8412480" cy="3291840"/>
+          </a:xfrm>
+          <a:prstGeom prst="rect">
+            <a:avLst/>
+          </a:prstGeom>
+          <a:noFill/>
+        </p:spPr>
+        <p:txBody>
+          <a:bodyPr wrap="square">
+            <a:spAutoFit/>
+          </a:bodyPr>
+          <a:lstStyle/>
+          <a:p>
+            <a:pPr>
+              <a:defRPr sz="1800">
+                <a:solidFill>
+                  <a:srgbClr val="141414"/>
+                </a:solidFill>
+                <a:latin typeface="Calibri"/>
+              </a:defRPr>
             </a:pPr>
             <a:r>
               <a:t>Slide 9 — Ablation strategy</a:t>
@@ -4310,7 +6517,12 @@
           </a:p>
           <a:p>
             <a:pPr>
-              <a:defRPr sz="1800"/>
+              <a:defRPr sz="1800">
+                <a:solidFill>
+                  <a:srgbClr val="141414"/>
+                </a:solidFill>
+                <a:latin typeface="Calibri"/>
+              </a:defRPr>
             </a:pPr>
             <a:r>
               <a:t>Baseline (135 features) vs Baseline + family (wavelet / MFCC / AR / connectivity)</a:t>
@@ -4318,7 +6530,12 @@
           </a:p>
           <a:p>
             <a:pPr>
-              <a:defRPr sz="1800"/>
+              <a:defRPr sz="1800">
+                <a:solidFill>
+                  <a:srgbClr val="141414"/>
+                </a:solidFill>
+                <a:latin typeface="Calibri"/>
+              </a:defRPr>
             </a:pPr>
             <a:r>
               <a:t>Use the same LOSO splits and compute paired Wilcoxon tests across folds</a:t>
@@ -4326,7 +6543,12 @@
           </a:p>
           <a:p>
             <a:pPr>
-              <a:defRPr sz="1800"/>
+              <a:defRPr sz="1800">
+                <a:solidFill>
+                  <a:srgbClr val="141414"/>
+                </a:solidFill>
+                <a:latin typeface="Calibri"/>
+              </a:defRPr>
             </a:pPr>
             <a:r>
               <a:t>Record fold-level outputs and config JSON for auditability</a:t>
@@ -4660,4 +6882,324 @@
   </a:objectDefaults>
   <a:extraClrSchemeLst/>
 </a:theme>
+</file>
+
+<file path=ppt/theme/theme2.xml><?xml version="1.0" encoding="utf-8"?>
+<a:theme xmlns:a="http://schemas.openxmlformats.org/drawingml/2006/main" name="Office Theme">
+  <a:themeElements>
+    <a:clrScheme name="Office">
+      <a:dk1>
+        <a:sysClr val="windowText" lastClr="000000"/>
+      </a:dk1>
+      <a:lt1>
+        <a:sysClr val="window" lastClr="FFFFFF"/>
+      </a:lt1>
+      <a:dk2>
+        <a:srgbClr val="1F497D"/>
+      </a:dk2>
+      <a:lt2>
+        <a:srgbClr val="EEECE1"/>
+      </a:lt2>
+      <a:accent1>
+        <a:srgbClr val="4F81BD"/>
+      </a:accent1>
+      <a:accent2>
+        <a:srgbClr val="C0504D"/>
+      </a:accent2>
+      <a:accent3>
+        <a:srgbClr val="9BBB59"/>
+      </a:accent3>
+      <a:accent4>
+        <a:srgbClr val="8064A2"/>
+      </a:accent4>
+      <a:accent5>
+        <a:srgbClr val="4BACC6"/>
+      </a:accent5>
+      <a:accent6>
+        <a:srgbClr val="F79646"/>
+      </a:accent6>
+      <a:hlink>
+        <a:srgbClr val="0000FF"/>
+      </a:hlink>
+      <a:folHlink>
+        <a:srgbClr val="800080"/>
+      </a:folHlink>
+    </a:clrScheme>
+    <a:fontScheme name="Office">
+      <a:majorFont>
+        <a:latin typeface="Calibri"/>
+        <a:ea typeface=""/>
+        <a:cs typeface=""/>
+        <a:font script="Jpan" typeface="ＭＳ Ｐゴシック"/>
+        <a:font script="Hang" typeface="맑은 고딕"/>
+        <a:font script="Hans" typeface="宋体"/>
+        <a:font script="Hant" typeface="新細明體"/>
+        <a:font script="Arab" typeface="Times New Roman"/>
+        <a:font script="Hebr" typeface="Times New Roman"/>
+        <a:font script="Thai" typeface="Angsana New"/>
+        <a:font script="Ethi" typeface="Nyala"/>
+        <a:font script="Beng" typeface="Vrinda"/>
+        <a:font script="Gujr" typeface="Shruti"/>
+        <a:font script="Khmr" typeface="MoolBoran"/>
+        <a:font script="Knda" typeface="Tunga"/>
+        <a:font script="Guru" typeface="Raavi"/>
+        <a:font script="Cans" typeface="Euphemia"/>
+        <a:font script="Cher" typeface="Plantagenet Cherokee"/>
+        <a:font script="Yiii" typeface="Microsoft Yi Baiti"/>
+        <a:font script="Tibt" typeface="Microsoft Himalaya"/>
+        <a:font script="Thaa" typeface="MV Boli"/>
+        <a:font script="Deva" typeface="Mangal"/>
+        <a:font script="Telu" typeface="Gautami"/>
+        <a:font script="Taml" typeface="Latha"/>
+        <a:font script="Syrc" typeface="Estrangelo Edessa"/>
+        <a:font script="Orya" typeface="Kalinga"/>
+        <a:font script="Mlym" typeface="Kartika"/>
+        <a:font script="Laoo" typeface="DokChampa"/>
+        <a:font script="Sinh" typeface="Iskoola Pota"/>
+        <a:font script="Mong" typeface="Mongolian Baiti"/>
+        <a:font script="Viet" typeface="Times New Roman"/>
+        <a:font script="Uigh" typeface="Microsoft Uighur"/>
+        <a:font script="Geor" typeface="Sylfaen"/>
+      </a:majorFont>
+      <a:minorFont>
+        <a:latin typeface="Calibri"/>
+        <a:ea typeface=""/>
+        <a:cs typeface=""/>
+        <a:font script="Jpan" typeface="ＭＳ Ｐゴシック"/>
+        <a:font script="Hang" typeface="맑은 고딕"/>
+        <a:font script="Hans" typeface="宋体"/>
+        <a:font script="Hant" typeface="新細明體"/>
+        <a:font script="Arab" typeface="Arial"/>
+        <a:font script="Hebr" typeface="Arial"/>
+        <a:font script="Thai" typeface="Cordia New"/>
+        <a:font script="Ethi" typeface="Nyala"/>
+        <a:font script="Beng" typeface="Vrinda"/>
+        <a:font script="Gujr" typeface="Shruti"/>
+        <a:font script="Khmr" typeface="DaunPenh"/>
+        <a:font script="Knda" typeface="Tunga"/>
+        <a:font script="Guru" typeface="Raavi"/>
+        <a:font script="Cans" typeface="Euphemia"/>
+        <a:font script="Cher" typeface="Plantagenet Cherokee"/>
+        <a:font script="Yiii" typeface="Microsoft Yi Baiti"/>
+        <a:font script="Tibt" typeface="Microsoft Himalaya"/>
+        <a:font script="Thaa" typeface="MV Boli"/>
+        <a:font script="Deva" typeface="Mangal"/>
+        <a:font script="Telu" typeface="Gautami"/>
+        <a:font script="Taml" typeface="Latha"/>
+        <a:font script="Syrc" typeface="Estrangelo Edessa"/>
+        <a:font script="Orya" typeface="Kalinga"/>
+        <a:font script="Mlym" typeface="Kartika"/>
+        <a:font script="Laoo" typeface="DokChampa"/>
+        <a:font script="Sinh" typeface="Iskoola Pota"/>
+        <a:font script="Mong" typeface="Mongolian Baiti"/>
+        <a:font script="Viet" typeface="Arial"/>
+        <a:font script="Uigh" typeface="Microsoft Uighur"/>
+        <a:font script="Geor" typeface="Sylfaen"/>
+      </a:minorFont>
+    </a:fontScheme>
+    <a:fmtScheme name="Office">
+      <a:fillStyleLst>
+        <a:solidFill>
+          <a:schemeClr val="phClr"/>
+        </a:solidFill>
+        <a:gradFill rotWithShape="1">
+          <a:gsLst>
+            <a:gs pos="0">
+              <a:schemeClr val="phClr">
+                <a:tint val="50000"/>
+                <a:satMod val="300000"/>
+              </a:schemeClr>
+            </a:gs>
+            <a:gs pos="35000">
+              <a:schemeClr val="phClr">
+                <a:tint val="37000"/>
+                <a:satMod val="300000"/>
+              </a:schemeClr>
+            </a:gs>
+            <a:gs pos="100000">
+              <a:schemeClr val="phClr">
+                <a:tint val="15000"/>
+                <a:satMod val="350000"/>
+              </a:schemeClr>
+            </a:gs>
+          </a:gsLst>
+          <a:lin ang="16200000" scaled="1"/>
+        </a:gradFill>
+        <a:gradFill rotWithShape="1">
+          <a:gsLst>
+            <a:gs pos="0">
+              <a:schemeClr val="phClr">
+                <a:tint val="100000"/>
+                <a:shade val="100000"/>
+                <a:satMod val="130000"/>
+              </a:schemeClr>
+            </a:gs>
+            <a:gs pos="100000">
+              <a:schemeClr val="phClr">
+                <a:tint val="50000"/>
+                <a:shade val="100000"/>
+                <a:satMod val="350000"/>
+              </a:schemeClr>
+            </a:gs>
+          </a:gsLst>
+          <a:lin ang="16200000" scaled="0"/>
+        </a:gradFill>
+      </a:fillStyleLst>
+      <a:lnStyleLst>
+        <a:ln w="9525" cap="flat" cmpd="sng" algn="ctr">
+          <a:solidFill>
+            <a:schemeClr val="phClr">
+              <a:shade val="95000"/>
+              <a:satMod val="105000"/>
+            </a:schemeClr>
+          </a:solidFill>
+          <a:prstDash val="solid"/>
+        </a:ln>
+        <a:ln w="25400" cap="flat" cmpd="sng" algn="ctr">
+          <a:solidFill>
+            <a:schemeClr val="phClr"/>
+          </a:solidFill>
+          <a:prstDash val="solid"/>
+        </a:ln>
+        <a:ln w="38100" cap="flat" cmpd="sng" algn="ctr">
+          <a:solidFill>
+            <a:schemeClr val="phClr"/>
+          </a:solidFill>
+          <a:prstDash val="solid"/>
+        </a:ln>
+      </a:lnStyleLst>
+      <a:effectStyleLst>
+        <a:effectStyle>
+          <a:effectLst>
+            <a:outerShdw blurRad="40000" dist="20000" dir="5400000" rotWithShape="0">
+              <a:srgbClr val="000000">
+                <a:alpha val="38000"/>
+              </a:srgbClr>
+            </a:outerShdw>
+          </a:effectLst>
+        </a:effectStyle>
+        <a:effectStyle>
+          <a:effectLst>
+            <a:outerShdw blurRad="40000" dist="23000" dir="5400000" rotWithShape="0">
+              <a:srgbClr val="000000">
+                <a:alpha val="35000"/>
+              </a:srgbClr>
+            </a:outerShdw>
+          </a:effectLst>
+        </a:effectStyle>
+        <a:effectStyle>
+          <a:effectLst>
+            <a:outerShdw blurRad="40000" dist="23000" dir="5400000" rotWithShape="0">
+              <a:srgbClr val="000000">
+                <a:alpha val="35000"/>
+              </a:srgbClr>
+            </a:outerShdw>
+          </a:effectLst>
+          <a:scene3d>
+            <a:camera prst="orthographicFront">
+              <a:rot lat="0" lon="0" rev="0"/>
+            </a:camera>
+            <a:lightRig rig="threePt" dir="t">
+              <a:rot lat="0" lon="0" rev="1200000"/>
+            </a:lightRig>
+          </a:scene3d>
+          <a:sp3d>
+            <a:bevelT w="63500" h="25400"/>
+          </a:sp3d>
+        </a:effectStyle>
+      </a:effectStyleLst>
+      <a:bgFillStyleLst>
+        <a:solidFill>
+          <a:schemeClr val="phClr"/>
+        </a:solidFill>
+        <a:gradFill rotWithShape="1">
+          <a:gsLst>
+            <a:gs pos="0">
+              <a:schemeClr val="phClr">
+                <a:tint val="40000"/>
+                <a:satMod val="350000"/>
+              </a:schemeClr>
+            </a:gs>
+            <a:gs pos="40000">
+              <a:schemeClr val="phClr">
+                <a:tint val="45000"/>
+                <a:shade val="99000"/>
+                <a:satMod val="350000"/>
+              </a:schemeClr>
+            </a:gs>
+            <a:gs pos="100000">
+              <a:schemeClr val="phClr">
+                <a:shade val="20000"/>
+                <a:satMod val="255000"/>
+              </a:schemeClr>
+            </a:gs>
+          </a:gsLst>
+          <a:path path="circle">
+            <a:fillToRect l="50000" t="-80000" r="50000" b="180000"/>
+          </a:path>
+        </a:gradFill>
+        <a:gradFill rotWithShape="1">
+          <a:gsLst>
+            <a:gs pos="0">
+              <a:schemeClr val="phClr">
+                <a:tint val="80000"/>
+                <a:satMod val="300000"/>
+              </a:schemeClr>
+            </a:gs>
+            <a:gs pos="100000">
+              <a:schemeClr val="phClr">
+                <a:shade val="30000"/>
+                <a:satMod val="200000"/>
+              </a:schemeClr>
+            </a:gs>
+          </a:gsLst>
+          <a:path path="circle">
+            <a:fillToRect l="50000" t="50000" r="50000" b="50000"/>
+          </a:path>
+        </a:gradFill>
+      </a:bgFillStyleLst>
+    </a:fmtScheme>
+  </a:themeElements>
+  <a:objectDefaults>
+    <a:spDef>
+      <a:spPr/>
+      <a:bodyPr/>
+      <a:lstStyle/>
+      <a:style>
+        <a:lnRef idx="1">
+          <a:schemeClr val="accent1"/>
+        </a:lnRef>
+        <a:fillRef idx="3">
+          <a:schemeClr val="accent1"/>
+        </a:fillRef>
+        <a:effectRef idx="2">
+          <a:schemeClr val="accent1"/>
+        </a:effectRef>
+        <a:fontRef idx="minor">
+          <a:schemeClr val="lt1"/>
+        </a:fontRef>
+      </a:style>
+    </a:spDef>
+    <a:lnDef>
+      <a:spPr/>
+      <a:bodyPr/>
+      <a:lstStyle/>
+      <a:style>
+        <a:lnRef idx="2">
+          <a:schemeClr val="accent1"/>
+        </a:lnRef>
+        <a:fillRef idx="0">
+          <a:schemeClr val="accent1"/>
+        </a:fillRef>
+        <a:effectRef idx="1">
+          <a:schemeClr val="accent1"/>
+        </a:effectRef>
+        <a:fontRef idx="minor">
+          <a:schemeClr val="tx1"/>
+        </a:fontRef>
+      </a:style>
+    </a:lnDef>
+  </a:objectDefaults>
+  <a:extraClrSchemeLst/>
+</a:theme>
 </file>
</xml_diff>